<commit_message>
Build G6 T4 Algebra: 6 PPTs (inquiry, cultural connections, video recs) + 7 fillable worksheets (5 topics + full revision + revision booklet)
</commit_message>
<xml_diff>
--- a/static/ppts/G6_Math_T4_Expressions.pptx
+++ b/static/ppts/G6_Math_T4_Expressions.pptx
@@ -10,9 +10,13 @@
     <p:sldId id="258" r:id="rId4"/>
     <p:sldId id="259" r:id="rId5"/>
     <p:sldId id="260" r:id="rId6"/>
+    <p:sldId id="261" r:id="rId7"/>
+    <p:sldId id="262" r:id="rId8"/>
+    <p:sldId id="263" r:id="rId9"/>
+    <p:sldId id="264" r:id="rId10"/>
   </p:sldIdLst>
   <p:notesMasterIdLst>
-    <p:notesMasterId r:id="rId7"/>
+    <p:notesMasterId r:id="rId11"/>
   </p:notesMasterIdLst>
   <p:sldSz cx="9144000" cy="5143500"/>
   <p:notesSz cx="5143500" cy="9144000"/>
@@ -882,6 +886,358 @@
             <a:fld id="{F7021451-1387-4CA6-816F-3879F97B5CBC}" type="slidenum">
               <a:rPr lang="en-US"/>
               <a:t>5</a:t>
+            </a:fld>
+            <a:endParaRPr lang="en-US"/>
+          </a:p>
+        </p:txBody>
+      </p:sp>
+    </p:spTree>
+    <p:extLst>
+      <p:ext uri="{BB962C8B-B14F-4D97-AF65-F5344CB8AC3E}">
+        <p14:creationId xmlns:p14="http://schemas.microsoft.com/office/powerpoint/2010/main" val="1024086991"/>
+      </p:ext>
+    </p:extLst>
+  </p:cSld>
+  <p:clrMapOvr>
+    <a:masterClrMapping/>
+  </p:clrMapOvr>
+</p:notes>
+</file>
+
+<file path=ppt/notesSlides/notesSlide6.xml><?xml version="1.0" encoding="utf-8"?>
+<p:notes xmlns:a="http://schemas.openxmlformats.org/drawingml/2006/main" xmlns:r="http://schemas.openxmlformats.org/officeDocument/2006/relationships" xmlns:p="http://schemas.openxmlformats.org/presentationml/2006/main">
+  <p:cSld>
+    <p:spTree>
+      <p:nvGrpSpPr>
+        <p:cNvPr id="1" name=""/>
+        <p:cNvGrpSpPr/>
+        <p:nvPr/>
+      </p:nvGrpSpPr>
+      <p:grpSpPr>
+        <a:xfrm>
+          <a:off x="0" y="0"/>
+          <a:ext cx="0" cy="0"/>
+          <a:chOff x="0" y="0"/>
+          <a:chExt cx="0" cy="0"/>
+        </a:xfrm>
+      </p:grpSpPr>
+      <p:sp>
+        <p:nvSpPr>
+          <p:cNvPr id="2" name="Slide Image Placeholder 1"/>
+          <p:cNvSpPr>
+            <a:spLocks noGrp="1" noRot="1" noChangeAspect="1"/>
+          </p:cNvSpPr>
+          <p:nvPr>
+            <p:ph type="sldImg"/>
+          </p:nvPr>
+        </p:nvSpPr>
+        <p:spPr/>
+      </p:sp>
+      <p:sp>
+        <p:nvSpPr>
+          <p:cNvPr id="3" name="Notes Placeholder 2"/>
+          <p:cNvSpPr>
+            <a:spLocks noGrp="1"/>
+          </p:cNvSpPr>
+          <p:nvPr>
+            <p:ph type="body" idx="1"/>
+          </p:nvPr>
+        </p:nvSpPr>
+        <p:spPr/>
+        <p:txBody>
+          <a:bodyPr/>
+          <a:lstStyle/>
+          <a:p>
+            <a:r>
+              <a:rPr lang="en-US" dirty="0"/>
+              <a:t/>
+            </a:r>
+            <a:endParaRPr lang="en-US" dirty="0"/>
+          </a:p>
+        </p:txBody>
+      </p:sp>
+      <p:sp>
+        <p:nvSpPr>
+          <p:cNvPr id="4" name="Slide Number Placeholder 3"/>
+          <p:cNvSpPr>
+            <a:spLocks noGrp="1"/>
+          </p:cNvSpPr>
+          <p:nvPr>
+            <p:ph type="sldNum" sz="quarter" idx="10"/>
+          </p:nvPr>
+        </p:nvSpPr>
+        <p:spPr/>
+        <p:txBody>
+          <a:bodyPr/>
+          <a:lstStyle/>
+          <a:p>
+            <a:fld id="{F7021451-1387-4CA6-816F-3879F97B5CBC}" type="slidenum">
+              <a:rPr lang="en-US"/>
+              <a:t>6</a:t>
+            </a:fld>
+            <a:endParaRPr lang="en-US"/>
+          </a:p>
+        </p:txBody>
+      </p:sp>
+    </p:spTree>
+    <p:extLst>
+      <p:ext uri="{BB962C8B-B14F-4D97-AF65-F5344CB8AC3E}">
+        <p14:creationId xmlns:p14="http://schemas.microsoft.com/office/powerpoint/2010/main" val="1024086991"/>
+      </p:ext>
+    </p:extLst>
+  </p:cSld>
+  <p:clrMapOvr>
+    <a:masterClrMapping/>
+  </p:clrMapOvr>
+</p:notes>
+</file>
+
+<file path=ppt/notesSlides/notesSlide7.xml><?xml version="1.0" encoding="utf-8"?>
+<p:notes xmlns:a="http://schemas.openxmlformats.org/drawingml/2006/main" xmlns:r="http://schemas.openxmlformats.org/officeDocument/2006/relationships" xmlns:p="http://schemas.openxmlformats.org/presentationml/2006/main">
+  <p:cSld>
+    <p:spTree>
+      <p:nvGrpSpPr>
+        <p:cNvPr id="1" name=""/>
+        <p:cNvGrpSpPr/>
+        <p:nvPr/>
+      </p:nvGrpSpPr>
+      <p:grpSpPr>
+        <a:xfrm>
+          <a:off x="0" y="0"/>
+          <a:ext cx="0" cy="0"/>
+          <a:chOff x="0" y="0"/>
+          <a:chExt cx="0" cy="0"/>
+        </a:xfrm>
+      </p:grpSpPr>
+      <p:sp>
+        <p:nvSpPr>
+          <p:cNvPr id="2" name="Slide Image Placeholder 1"/>
+          <p:cNvSpPr>
+            <a:spLocks noGrp="1" noRot="1" noChangeAspect="1"/>
+          </p:cNvSpPr>
+          <p:nvPr>
+            <p:ph type="sldImg"/>
+          </p:nvPr>
+        </p:nvSpPr>
+        <p:spPr/>
+      </p:sp>
+      <p:sp>
+        <p:nvSpPr>
+          <p:cNvPr id="3" name="Notes Placeholder 2"/>
+          <p:cNvSpPr>
+            <a:spLocks noGrp="1"/>
+          </p:cNvSpPr>
+          <p:nvPr>
+            <p:ph type="body" idx="1"/>
+          </p:nvPr>
+        </p:nvSpPr>
+        <p:spPr/>
+        <p:txBody>
+          <a:bodyPr/>
+          <a:lstStyle/>
+          <a:p>
+            <a:r>
+              <a:rPr lang="en-US" dirty="0"/>
+              <a:t/>
+            </a:r>
+            <a:endParaRPr lang="en-US" dirty="0"/>
+          </a:p>
+        </p:txBody>
+      </p:sp>
+      <p:sp>
+        <p:nvSpPr>
+          <p:cNvPr id="4" name="Slide Number Placeholder 3"/>
+          <p:cNvSpPr>
+            <a:spLocks noGrp="1"/>
+          </p:cNvSpPr>
+          <p:nvPr>
+            <p:ph type="sldNum" sz="quarter" idx="10"/>
+          </p:nvPr>
+        </p:nvSpPr>
+        <p:spPr/>
+        <p:txBody>
+          <a:bodyPr/>
+          <a:lstStyle/>
+          <a:p>
+            <a:fld id="{F7021451-1387-4CA6-816F-3879F97B5CBC}" type="slidenum">
+              <a:rPr lang="en-US"/>
+              <a:t>7</a:t>
+            </a:fld>
+            <a:endParaRPr lang="en-US"/>
+          </a:p>
+        </p:txBody>
+      </p:sp>
+    </p:spTree>
+    <p:extLst>
+      <p:ext uri="{BB962C8B-B14F-4D97-AF65-F5344CB8AC3E}">
+        <p14:creationId xmlns:p14="http://schemas.microsoft.com/office/powerpoint/2010/main" val="1024086991"/>
+      </p:ext>
+    </p:extLst>
+  </p:cSld>
+  <p:clrMapOvr>
+    <a:masterClrMapping/>
+  </p:clrMapOvr>
+</p:notes>
+</file>
+
+<file path=ppt/notesSlides/notesSlide8.xml><?xml version="1.0" encoding="utf-8"?>
+<p:notes xmlns:a="http://schemas.openxmlformats.org/drawingml/2006/main" xmlns:r="http://schemas.openxmlformats.org/officeDocument/2006/relationships" xmlns:p="http://schemas.openxmlformats.org/presentationml/2006/main">
+  <p:cSld>
+    <p:spTree>
+      <p:nvGrpSpPr>
+        <p:cNvPr id="1" name=""/>
+        <p:cNvGrpSpPr/>
+        <p:nvPr/>
+      </p:nvGrpSpPr>
+      <p:grpSpPr>
+        <a:xfrm>
+          <a:off x="0" y="0"/>
+          <a:ext cx="0" cy="0"/>
+          <a:chOff x="0" y="0"/>
+          <a:chExt cx="0" cy="0"/>
+        </a:xfrm>
+      </p:grpSpPr>
+      <p:sp>
+        <p:nvSpPr>
+          <p:cNvPr id="2" name="Slide Image Placeholder 1"/>
+          <p:cNvSpPr>
+            <a:spLocks noGrp="1" noRot="1" noChangeAspect="1"/>
+          </p:cNvSpPr>
+          <p:nvPr>
+            <p:ph type="sldImg"/>
+          </p:nvPr>
+        </p:nvSpPr>
+        <p:spPr/>
+      </p:sp>
+      <p:sp>
+        <p:nvSpPr>
+          <p:cNvPr id="3" name="Notes Placeholder 2"/>
+          <p:cNvSpPr>
+            <a:spLocks noGrp="1"/>
+          </p:cNvSpPr>
+          <p:nvPr>
+            <p:ph type="body" idx="1"/>
+          </p:nvPr>
+        </p:nvSpPr>
+        <p:spPr/>
+        <p:txBody>
+          <a:bodyPr/>
+          <a:lstStyle/>
+          <a:p>
+            <a:r>
+              <a:rPr lang="en-US" dirty="0"/>
+              <a:t/>
+            </a:r>
+            <a:endParaRPr lang="en-US" dirty="0"/>
+          </a:p>
+        </p:txBody>
+      </p:sp>
+      <p:sp>
+        <p:nvSpPr>
+          <p:cNvPr id="4" name="Slide Number Placeholder 3"/>
+          <p:cNvSpPr>
+            <a:spLocks noGrp="1"/>
+          </p:cNvSpPr>
+          <p:nvPr>
+            <p:ph type="sldNum" sz="quarter" idx="10"/>
+          </p:nvPr>
+        </p:nvSpPr>
+        <p:spPr/>
+        <p:txBody>
+          <a:bodyPr/>
+          <a:lstStyle/>
+          <a:p>
+            <a:fld id="{F7021451-1387-4CA6-816F-3879F97B5CBC}" type="slidenum">
+              <a:rPr lang="en-US"/>
+              <a:t>8</a:t>
+            </a:fld>
+            <a:endParaRPr lang="en-US"/>
+          </a:p>
+        </p:txBody>
+      </p:sp>
+    </p:spTree>
+    <p:extLst>
+      <p:ext uri="{BB962C8B-B14F-4D97-AF65-F5344CB8AC3E}">
+        <p14:creationId xmlns:p14="http://schemas.microsoft.com/office/powerpoint/2010/main" val="1024086991"/>
+      </p:ext>
+    </p:extLst>
+  </p:cSld>
+  <p:clrMapOvr>
+    <a:masterClrMapping/>
+  </p:clrMapOvr>
+</p:notes>
+</file>
+
+<file path=ppt/notesSlides/notesSlide9.xml><?xml version="1.0" encoding="utf-8"?>
+<p:notes xmlns:a="http://schemas.openxmlformats.org/drawingml/2006/main" xmlns:r="http://schemas.openxmlformats.org/officeDocument/2006/relationships" xmlns:p="http://schemas.openxmlformats.org/presentationml/2006/main">
+  <p:cSld>
+    <p:spTree>
+      <p:nvGrpSpPr>
+        <p:cNvPr id="1" name=""/>
+        <p:cNvGrpSpPr/>
+        <p:nvPr/>
+      </p:nvGrpSpPr>
+      <p:grpSpPr>
+        <a:xfrm>
+          <a:off x="0" y="0"/>
+          <a:ext cx="0" cy="0"/>
+          <a:chOff x="0" y="0"/>
+          <a:chExt cx="0" cy="0"/>
+        </a:xfrm>
+      </p:grpSpPr>
+      <p:sp>
+        <p:nvSpPr>
+          <p:cNvPr id="2" name="Slide Image Placeholder 1"/>
+          <p:cNvSpPr>
+            <a:spLocks noGrp="1" noRot="1" noChangeAspect="1"/>
+          </p:cNvSpPr>
+          <p:nvPr>
+            <p:ph type="sldImg"/>
+          </p:nvPr>
+        </p:nvSpPr>
+        <p:spPr/>
+      </p:sp>
+      <p:sp>
+        <p:nvSpPr>
+          <p:cNvPr id="3" name="Notes Placeholder 2"/>
+          <p:cNvSpPr>
+            <a:spLocks noGrp="1"/>
+          </p:cNvSpPr>
+          <p:nvPr>
+            <p:ph type="body" idx="1"/>
+          </p:nvPr>
+        </p:nvSpPr>
+        <p:spPr/>
+        <p:txBody>
+          <a:bodyPr/>
+          <a:lstStyle/>
+          <a:p>
+            <a:r>
+              <a:rPr lang="en-US" dirty="0"/>
+              <a:t/>
+            </a:r>
+            <a:endParaRPr lang="en-US" dirty="0"/>
+          </a:p>
+        </p:txBody>
+      </p:sp>
+      <p:sp>
+        <p:nvSpPr>
+          <p:cNvPr id="4" name="Slide Number Placeholder 3"/>
+          <p:cNvSpPr>
+            <a:spLocks noGrp="1"/>
+          </p:cNvSpPr>
+          <p:nvPr>
+            <p:ph type="sldNum" sz="quarter" idx="10"/>
+          </p:nvPr>
+        </p:nvSpPr>
+        <p:spPr/>
+        <p:txBody>
+          <a:bodyPr/>
+          <a:lstStyle/>
+          <a:p>
+            <a:fld id="{F7021451-1387-4CA6-816F-3879F97B5CBC}" type="slidenum">
+              <a:rPr lang="en-US"/>
+              <a:t>9</a:t>
             </a:fld>
             <a:endParaRPr lang="en-US"/>
           </a:p>
@@ -1210,13 +1566,6 @@
 <file path=ppt/slides/slide1.xml><?xml version="1.0" encoding="utf-8"?>
 <p:sld xmlns:a="http://schemas.openxmlformats.org/drawingml/2006/main" xmlns:r="http://schemas.openxmlformats.org/officeDocument/2006/relationships" xmlns:p="http://schemas.openxmlformats.org/presentationml/2006/main">
   <p:cSld name="Slide 1">
-    <p:bg>
-      <p:bgPr>
-        <a:solidFill>
-          <a:srgbClr val="1B2A4A"/>
-        </a:solidFill>
-      </p:bgPr>
-    </p:bg>
     <p:spTree>
       <p:nvGrpSpPr>
         <p:cNvPr id="1" name=""/>
@@ -1240,7 +1589,27 @@
         <p:spPr>
           <a:xfrm>
             <a:off x="0" y="0"/>
-            <a:ext cx="109728" cy="5143500"/>
+            <a:ext cx="9144000" cy="5143500"/>
+          </a:xfrm>
+          <a:prstGeom prst="rect">
+            <a:avLst/>
+          </a:prstGeom>
+          <a:solidFill>
+            <a:srgbClr val="1B2A4A"/>
+          </a:solidFill>
+          <a:ln/>
+        </p:spPr>
+      </p:sp>
+      <p:sp>
+        <p:nvSpPr>
+          <p:cNvPr id="3" name="Shape 1"/>
+          <p:cNvSpPr/>
+          <p:nvPr/>
+        </p:nvSpPr>
+        <p:spPr>
+          <a:xfrm>
+            <a:off x="0" y="4777740"/>
+            <a:ext cx="9144000" cy="365760"/>
           </a:xfrm>
           <a:prstGeom prst="rect">
             <a:avLst/>
@@ -1253,14 +1622,14 @@
       </p:sp>
       <p:sp>
         <p:nvSpPr>
-          <p:cNvPr id="3" name="Text 1"/>
+          <p:cNvPr id="4" name="Text 2"/>
           <p:cNvSpPr/>
           <p:nvPr/>
         </p:nvSpPr>
         <p:spPr>
           <a:xfrm>
             <a:off x="731520" y="1097280"/>
-            <a:ext cx="7772400" cy="1371600"/>
+            <a:ext cx="7680960" cy="457200"/>
           </a:xfrm>
           <a:prstGeom prst="rect">
             <a:avLst/>
@@ -1270,6 +1639,45 @@
         </p:spPr>
         <p:txBody>
           <a:bodyPr wrap="square" rtlCol="0" anchor="ctr"/>
+          <a:lstStyle/>
+          <a:p>
+            <a:pPr indent="0" marL="0">
+              <a:buNone/>
+            </a:pPr>
+            <a:r>
+              <a:rPr lang="en-US" sz="1400" b="1" spc="400" kern="0" dirty="0">
+                <a:solidFill>
+                  <a:srgbClr val="2A9D8F"/>
+                </a:solidFill>
+                <a:latin typeface="Calibri" pitchFamily="34" charset="0"/>
+                <a:ea typeface="Calibri" pitchFamily="34" charset="-122"/>
+                <a:cs typeface="Calibri" pitchFamily="34" charset="-120"/>
+              </a:rPr>
+              <a:t>GRADE 6 MATHEMATICS</a:t>
+            </a:r>
+            <a:endParaRPr lang="en-US" sz="1400" dirty="0"/>
+          </a:p>
+        </p:txBody>
+      </p:sp>
+      <p:sp>
+        <p:nvSpPr>
+          <p:cNvPr id="5" name="Text 3"/>
+          <p:cNvSpPr/>
+          <p:nvPr/>
+        </p:nvSpPr>
+        <p:spPr>
+          <a:xfrm>
+            <a:off x="731520" y="1645920"/>
+            <a:ext cx="7680960" cy="1463040"/>
+          </a:xfrm>
+          <a:prstGeom prst="rect">
+            <a:avLst/>
+          </a:prstGeom>
+          <a:noFill/>
+          <a:ln/>
+        </p:spPr>
+        <p:txBody>
+          <a:bodyPr wrap="square" rtlCol="0" anchor="t"/>
           <a:lstStyle/>
           <a:p>
             <a:pPr indent="0" marL="0">
@@ -1284,46 +1692,63 @@
                 <a:ea typeface="Georgia" pitchFamily="34" charset="-122"/>
                 <a:cs typeface="Georgia" pitchFamily="34" charset="-120"/>
               </a:rPr>
-              <a:t>Writing Algebraic Expressions</a:t>
+              <a:t>Writing Algebraic</a:t>
             </a:r>
             <a:endParaRPr lang="en-US" sz="4000" dirty="0"/>
           </a:p>
-        </p:txBody>
-      </p:sp>
-      <p:sp>
-        <p:nvSpPr>
-          <p:cNvPr id="4" name="Text 2"/>
-          <p:cNvSpPr/>
-          <p:nvPr/>
-        </p:nvSpPr>
-        <p:spPr>
-          <a:xfrm>
-            <a:off x="731520" y="2560320"/>
-            <a:ext cx="7772400" cy="548640"/>
-          </a:xfrm>
-          <a:prstGeom prst="rect">
-            <a:avLst/>
-          </a:prstGeom>
-          <a:noFill/>
-          <a:ln/>
-        </p:spPr>
-        <p:txBody>
-          <a:bodyPr wrap="square" rtlCol="0" anchor="ctr"/>
-          <a:lstStyle/>
           <a:p>
             <a:pPr indent="0" marL="0">
               <a:buNone/>
             </a:pPr>
             <a:r>
-              <a:rPr lang="en-US" sz="1600" dirty="0">
+              <a:rPr lang="en-US" sz="4000" b="1" dirty="0">
                 <a:solidFill>
-                  <a:srgbClr val="E9C46A"/>
+                  <a:srgbClr val="FFFFFF"/>
+                </a:solidFill>
+                <a:latin typeface="Georgia" pitchFamily="34" charset="0"/>
+                <a:ea typeface="Georgia" pitchFamily="34" charset="-122"/>
+                <a:cs typeface="Georgia" pitchFamily="34" charset="-120"/>
+              </a:rPr>
+              <a:t>Expressions</a:t>
+            </a:r>
+            <a:endParaRPr lang="en-US" sz="4000" dirty="0"/>
+          </a:p>
+        </p:txBody>
+      </p:sp>
+      <p:sp>
+        <p:nvSpPr>
+          <p:cNvPr id="6" name="Text 4"/>
+          <p:cNvSpPr/>
+          <p:nvPr/>
+        </p:nvSpPr>
+        <p:spPr>
+          <a:xfrm>
+            <a:off x="731520" y="3200400"/>
+            <a:ext cx="7680960" cy="548640"/>
+          </a:xfrm>
+          <a:prstGeom prst="rect">
+            <a:avLst/>
+          </a:prstGeom>
+          <a:noFill/>
+          <a:ln/>
+        </p:spPr>
+        <p:txBody>
+          <a:bodyPr wrap="square" rtlCol="0" anchor="ctr"/>
+          <a:lstStyle/>
+          <a:p>
+            <a:pPr indent="0" marL="0">
+              <a:buNone/>
+            </a:pPr>
+            <a:r>
+              <a:rPr lang="en-US" sz="1600" i="1" dirty="0">
+                <a:solidFill>
+                  <a:srgbClr val="9B9690"/>
                 </a:solidFill>
                 <a:latin typeface="Calibri" pitchFamily="34" charset="0"/>
                 <a:ea typeface="Calibri" pitchFamily="34" charset="-122"/>
                 <a:cs typeface="Calibri" pitchFamily="34" charset="-120"/>
               </a:rPr>
-              <a:t>Grade 6 Mathematics · Mr Zocchi</a:t>
+              <a:t>Using letters to represent numbers</a:t>
             </a:r>
             <a:endParaRPr lang="en-US" sz="1600" dirty="0"/>
           </a:p>
@@ -1331,36 +1756,14 @@
       </p:sp>
       <p:sp>
         <p:nvSpPr>
-          <p:cNvPr id="5" name="Shape 3"/>
-          <p:cNvSpPr/>
-          <p:nvPr/>
-        </p:nvSpPr>
-        <p:spPr>
-          <a:xfrm>
-            <a:off x="731520" y="3474720"/>
-            <a:ext cx="2011680" cy="411480"/>
-          </a:xfrm>
-          <a:prstGeom prst="roundRect">
-            <a:avLst>
-              <a:gd name="adj" fmla="val 17778"/>
-            </a:avLst>
-          </a:prstGeom>
-          <a:solidFill>
-            <a:srgbClr val="2A9D8F"/>
-          </a:solidFill>
-          <a:ln/>
-        </p:spPr>
-      </p:sp>
-      <p:sp>
-        <p:nvSpPr>
-          <p:cNvPr id="6" name="Text 4"/>
-          <p:cNvSpPr/>
-          <p:nvPr/>
-        </p:nvSpPr>
-        <p:spPr>
-          <a:xfrm>
-            <a:off x="731520" y="3474720"/>
-            <a:ext cx="2011680" cy="411480"/>
+          <p:cNvPr id="7" name="Text 5"/>
+          <p:cNvSpPr/>
+          <p:nvPr/>
+        </p:nvSpPr>
+        <p:spPr>
+          <a:xfrm>
+            <a:off x="731520" y="4206240"/>
+            <a:ext cx="3657600" cy="365760"/>
           </a:xfrm>
           <a:prstGeom prst="rect">
             <a:avLst/>
@@ -1372,19 +1775,19 @@
           <a:bodyPr wrap="square" rtlCol="0" anchor="ctr"/>
           <a:lstStyle/>
           <a:p>
-            <a:pPr algn="ctr" indent="0" marL="0">
+            <a:pPr indent="0" marL="0">
               <a:buNone/>
             </a:pPr>
             <a:r>
-              <a:rPr lang="en-US" sz="1200" b="1" dirty="0">
+              <a:rPr lang="en-US" sz="1200" dirty="0">
                 <a:solidFill>
-                  <a:srgbClr val="FFFFFF"/>
+                  <a:srgbClr val="6B6660"/>
                 </a:solidFill>
                 <a:latin typeface="Calibri" pitchFamily="34" charset="0"/>
                 <a:ea typeface="Calibri" pitchFamily="34" charset="-122"/>
                 <a:cs typeface="Calibri" pitchFamily="34" charset="-120"/>
               </a:rPr>
-              <a:t>Term 4 · Algebra</a:t>
+              <a:t>Mr Zocchi</a:t>
             </a:r>
             <a:endParaRPr lang="en-US" sz="1200" dirty="0"/>
           </a:p>
@@ -1401,13 +1804,6 @@
 <file path=ppt/slides/slide2.xml><?xml version="1.0" encoding="utf-8"?>
 <p:sld xmlns:a="http://schemas.openxmlformats.org/drawingml/2006/main" xmlns:r="http://schemas.openxmlformats.org/officeDocument/2006/relationships" xmlns:p="http://schemas.openxmlformats.org/presentationml/2006/main">
   <p:cSld name="Slide 2">
-    <p:bg>
-      <p:bgPr>
-        <a:solidFill>
-          <a:srgbClr val="FAF8F5"/>
-        </a:solidFill>
-      </p:bgPr>
-    </p:bg>
     <p:spTree>
       <p:nvGrpSpPr>
         <p:cNvPr id="1" name=""/>
@@ -1431,13 +1827,13 @@
         <p:spPr>
           <a:xfrm>
             <a:off x="0" y="0"/>
-            <a:ext cx="9144000" cy="54864"/>
+            <a:ext cx="9144000" cy="5143500"/>
           </a:xfrm>
           <a:prstGeom prst="rect">
             <a:avLst/>
           </a:prstGeom>
           <a:solidFill>
-            <a:srgbClr val="2A9D8F"/>
+            <a:srgbClr val="111D35"/>
           </a:solidFill>
           <a:ln/>
         </p:spPr>
@@ -1450,8 +1846,8 @@
         </p:nvSpPr>
         <p:spPr>
           <a:xfrm>
-            <a:off x="7772400" y="4709160"/>
-            <a:ext cx="1097280" cy="320040"/>
+            <a:off x="6858000" y="182880"/>
+            <a:ext cx="2286000" cy="2743200"/>
           </a:xfrm>
           <a:prstGeom prst="rect">
             <a:avLst/>
@@ -1463,86 +1859,75 @@
           <a:bodyPr wrap="square" rtlCol="0" anchor="ctr"/>
           <a:lstStyle/>
           <a:p>
-            <a:pPr algn="r" indent="0" marL="0">
+            <a:pPr algn="ctr" indent="0" marL="0">
               <a:buNone/>
             </a:pPr>
             <a:r>
-              <a:rPr lang="en-US" sz="900" dirty="0">
+              <a:rPr lang="en-US" sz="16000" b="1" dirty="0">
                 <a:solidFill>
-                  <a:srgbClr val="6B6660"/>
+                  <a:srgbClr val="2A9D8F">
+                    <a:alpha val="80000"/>
+                  </a:srgbClr>
+                </a:solidFill>
+                <a:latin typeface="Georgia" pitchFamily="34" charset="0"/>
+                <a:ea typeface="Georgia" pitchFamily="34" charset="-122"/>
+                <a:cs typeface="Georgia" pitchFamily="34" charset="-120"/>
+              </a:rPr>
+              <a:t>?</a:t>
+            </a:r>
+            <a:endParaRPr lang="en-US" sz="16000" dirty="0"/>
+          </a:p>
+        </p:txBody>
+      </p:sp>
+      <p:sp>
+        <p:nvSpPr>
+          <p:cNvPr id="4" name="Text 2"/>
+          <p:cNvSpPr/>
+          <p:nvPr/>
+        </p:nvSpPr>
+        <p:spPr>
+          <a:xfrm>
+            <a:off x="731520" y="548640"/>
+            <a:ext cx="2743200" cy="365760"/>
+          </a:xfrm>
+          <a:prstGeom prst="rect">
+            <a:avLst/>
+          </a:prstGeom>
+          <a:noFill/>
+          <a:ln/>
+        </p:spPr>
+        <p:txBody>
+          <a:bodyPr wrap="square" rtlCol="0" anchor="ctr"/>
+          <a:lstStyle/>
+          <a:p>
+            <a:pPr indent="0" marL="0">
+              <a:buNone/>
+            </a:pPr>
+            <a:r>
+              <a:rPr lang="en-US" sz="1200" b="1" spc="400" kern="0" dirty="0">
+                <a:solidFill>
+                  <a:srgbClr val="2A9D8F"/>
                 </a:solidFill>
                 <a:latin typeface="Calibri" pitchFamily="34" charset="0"/>
                 <a:ea typeface="Calibri" pitchFamily="34" charset="-122"/>
                 <a:cs typeface="Calibri" pitchFamily="34" charset="-120"/>
               </a:rPr>
-              <a:t>2 / 5</a:t>
-            </a:r>
-            <a:endParaRPr lang="en-US" sz="900" dirty="0"/>
-          </a:p>
-        </p:txBody>
-      </p:sp>
-      <p:sp>
-        <p:nvSpPr>
-          <p:cNvPr id="4" name="Shape 2"/>
-          <p:cNvSpPr/>
-          <p:nvPr/>
-        </p:nvSpPr>
-        <p:spPr>
-          <a:xfrm>
-            <a:off x="1371600" y="914400"/>
-            <a:ext cx="6400800" cy="3200400"/>
-          </a:xfrm>
-          <a:prstGeom prst="rect">
-            <a:avLst/>
-          </a:prstGeom>
-          <a:solidFill>
-            <a:srgbClr val="FFFFFF"/>
-          </a:solidFill>
-          <a:ln w="12700">
-            <a:solidFill>
-              <a:srgbClr val="E5E2DC"/>
-            </a:solidFill>
-            <a:prstDash val="solid"/>
-          </a:ln>
-          <a:effectLst>
-            <a:outerShdw sx="100000" sy="100000" kx="0" ky="0" algn="bl" rotWithShape="0" blurRad="50800" dist="25400" dir="8100000">
-              <a:srgbClr val="000000">
-                <a:alpha val="10000"/>
-              </a:srgbClr>
-            </a:outerShdw>
-          </a:effectLst>
-        </p:spPr>
-      </p:sp>
-      <p:sp>
-        <p:nvSpPr>
-          <p:cNvPr id="5" name="Shape 3"/>
-          <p:cNvSpPr/>
-          <p:nvPr/>
-        </p:nvSpPr>
-        <p:spPr>
-          <a:xfrm>
-            <a:off x="1371600" y="914400"/>
-            <a:ext cx="91440" cy="3200400"/>
-          </a:xfrm>
-          <a:prstGeom prst="rect">
-            <a:avLst/>
-          </a:prstGeom>
-          <a:solidFill>
-            <a:srgbClr val="2A9D8F"/>
-          </a:solidFill>
-          <a:ln/>
-        </p:spPr>
-      </p:sp>
-      <p:sp>
-        <p:nvSpPr>
-          <p:cNvPr id="6" name="Text 4"/>
-          <p:cNvSpPr/>
-          <p:nvPr/>
-        </p:nvSpPr>
-        <p:spPr>
-          <a:xfrm>
-            <a:off x="1828800" y="1097280"/>
-            <a:ext cx="5669280" cy="640080"/>
+              <a:t>INQUIRY</a:t>
+            </a:r>
+            <a:endParaRPr lang="en-US" sz="1200" dirty="0"/>
+          </a:p>
+        </p:txBody>
+      </p:sp>
+      <p:sp>
+        <p:nvSpPr>
+          <p:cNvPr id="5" name="Text 3"/>
+          <p:cNvSpPr/>
+          <p:nvPr/>
+        </p:nvSpPr>
+        <p:spPr>
+          <a:xfrm>
+            <a:off x="731520" y="1005840"/>
+            <a:ext cx="6858000" cy="1463040"/>
           </a:xfrm>
           <a:prstGeom prst="rect">
             <a:avLst/>
@@ -1551,37 +1936,37 @@
           <a:ln/>
         </p:spPr>
         <p:txBody>
-          <a:bodyPr wrap="square" rtlCol="0" anchor="ctr"/>
+          <a:bodyPr wrap="square" rtlCol="0" anchor="t"/>
           <a:lstStyle/>
           <a:p>
             <a:pPr indent="0" marL="0">
               <a:buNone/>
             </a:pPr>
             <a:r>
-              <a:rPr lang="en-US" sz="2400" b="1" dirty="0">
+              <a:rPr lang="en-US" sz="2800" b="1" dirty="0">
                 <a:solidFill>
-                  <a:srgbClr val="1B2A4A"/>
+                  <a:srgbClr val="FFFFFF"/>
                 </a:solidFill>
                 <a:latin typeface="Georgia" pitchFamily="34" charset="0"/>
                 <a:ea typeface="Georgia" pitchFamily="34" charset="-122"/>
                 <a:cs typeface="Georgia" pitchFamily="34" charset="-120"/>
               </a:rPr>
-              <a:t>What is Algebra?</a:t>
-            </a:r>
-            <a:endParaRPr lang="en-US" sz="2400" dirty="0"/>
-          </a:p>
-        </p:txBody>
-      </p:sp>
-      <p:sp>
-        <p:nvSpPr>
-          <p:cNvPr id="7" name="Text 5"/>
-          <p:cNvSpPr/>
-          <p:nvPr/>
-        </p:nvSpPr>
-        <p:spPr>
-          <a:xfrm>
-            <a:off x="1828800" y="1828800"/>
-            <a:ext cx="5669280" cy="2011680"/>
+              <a:t>A Nanjing metro ticket costs ¥2 base + ¥1 per station. Can you write a rule that works for ANY number of stations?</a:t>
+            </a:r>
+            <a:endParaRPr lang="en-US" sz="2800" dirty="0"/>
+          </a:p>
+        </p:txBody>
+      </p:sp>
+      <p:sp>
+        <p:nvSpPr>
+          <p:cNvPr id="6" name="Text 4"/>
+          <p:cNvSpPr/>
+          <p:nvPr/>
+        </p:nvSpPr>
+        <p:spPr>
+          <a:xfrm>
+            <a:off x="731520" y="2560320"/>
+            <a:ext cx="6858000" cy="548640"/>
           </a:xfrm>
           <a:prstGeom prst="rect">
             <a:avLst/>
@@ -1590,27 +1975,168 @@
           <a:ln/>
         </p:spPr>
         <p:txBody>
-          <a:bodyPr wrap="square" rtlCol="0" anchor="t"/>
+          <a:bodyPr wrap="square" rtlCol="0" anchor="ctr"/>
           <a:lstStyle/>
           <a:p>
             <a:pPr indent="0" marL="0">
-              <a:lnSpc>
-                <a:spcPct val="130000"/>
-              </a:lnSpc>
               <a:buNone/>
             </a:pPr>
             <a:r>
-              <a:rPr lang="en-US" sz="1500" dirty="0">
+              <a:rPr lang="en-US" sz="1400" i="1" dirty="0">
                 <a:solidFill>
-                  <a:srgbClr val="3D3A36"/>
+                  <a:srgbClr val="9B9690"/>
                 </a:solidFill>
                 <a:latin typeface="Calibri" pitchFamily="34" charset="0"/>
                 <a:ea typeface="Calibri" pitchFamily="34" charset="-122"/>
                 <a:cs typeface="Calibri" pitchFamily="34" charset="-120"/>
               </a:rPr>
-              <a:t>Algebra uses letters to represent unknown or variable numbers. Instead of writing 'a number plus 5', we write n + 5. This allows us to describe patterns, write rules, and solve problems. The letter is called a variable because its value can vary.</a:t>
-            </a:r>
-            <a:endParaRPr lang="en-US" sz="1500" dirty="0"/>
+              <a:t>Algebra lets us write rules that work for every possible input — not just one answer.</a:t>
+            </a:r>
+            <a:endParaRPr lang="en-US" sz="1400" dirty="0"/>
+          </a:p>
+        </p:txBody>
+      </p:sp>
+      <p:sp>
+        <p:nvSpPr>
+          <p:cNvPr id="7" name="Shape 5"/>
+          <p:cNvSpPr/>
+          <p:nvPr/>
+        </p:nvSpPr>
+        <p:spPr>
+          <a:xfrm>
+            <a:off x="548640" y="3200400"/>
+            <a:ext cx="7315200" cy="1645920"/>
+          </a:xfrm>
+          <a:prstGeom prst="rect">
+            <a:avLst/>
+          </a:prstGeom>
+          <a:solidFill>
+            <a:srgbClr val="243660"/>
+          </a:solidFill>
+          <a:ln/>
+        </p:spPr>
+      </p:sp>
+      <p:sp>
+        <p:nvSpPr>
+          <p:cNvPr id="8" name="Text 6"/>
+          <p:cNvSpPr/>
+          <p:nvPr/>
+        </p:nvSpPr>
+        <p:spPr>
+          <a:xfrm>
+            <a:off x="731520" y="3246120"/>
+            <a:ext cx="3657600" cy="320040"/>
+          </a:xfrm>
+          <a:prstGeom prst="rect">
+            <a:avLst/>
+          </a:prstGeom>
+          <a:noFill/>
+          <a:ln/>
+        </p:spPr>
+        <p:txBody>
+          <a:bodyPr wrap="square" rtlCol="0" anchor="ctr"/>
+          <a:lstStyle/>
+          <a:p>
+            <a:pPr indent="0" marL="0">
+              <a:buNone/>
+            </a:pPr>
+            <a:r>
+              <a:rPr lang="en-US" sz="1100" b="1" spc="200" kern="0" dirty="0">
+                <a:solidFill>
+                  <a:srgbClr val="2A9D8F"/>
+                </a:solidFill>
+                <a:latin typeface="Calibri" pitchFamily="34" charset="0"/>
+                <a:ea typeface="Calibri" pitchFamily="34" charset="-122"/>
+                <a:cs typeface="Calibri" pitchFamily="34" charset="-120"/>
+              </a:rPr>
+              <a:t>Think — Pair — Share</a:t>
+            </a:r>
+            <a:endParaRPr lang="en-US" sz="1100" dirty="0"/>
+          </a:p>
+        </p:txBody>
+      </p:sp>
+      <p:sp>
+        <p:nvSpPr>
+          <p:cNvPr id="9" name="Text 7"/>
+          <p:cNvSpPr/>
+          <p:nvPr/>
+        </p:nvSpPr>
+        <p:spPr>
+          <a:xfrm>
+            <a:off x="731520" y="3566160"/>
+            <a:ext cx="6949440" cy="1188720"/>
+          </a:xfrm>
+          <a:prstGeom prst="rect">
+            <a:avLst/>
+          </a:prstGeom>
+          <a:noFill/>
+          <a:ln/>
+        </p:spPr>
+        <p:txBody>
+          <a:bodyPr wrap="square" rtlCol="0" anchor="ctr"/>
+          <a:lstStyle/>
+          <a:p>
+            <a:pPr marL="342900" indent="-342900">
+              <a:spcAft>
+                <a:spcPts val="600"/>
+              </a:spcAft>
+              <a:buSzPct val="100000"/>
+              <a:buChar char="•"/>
+            </a:pPr>
+            <a:r>
+              <a:rPr lang="en-US" sz="1400" dirty="0">
+                <a:solidFill>
+                  <a:srgbClr val="E5E2DC"/>
+                </a:solidFill>
+                <a:latin typeface="Calibri" pitchFamily="34" charset="0"/>
+                <a:ea typeface="Calibri" pitchFamily="34" charset="-122"/>
+                <a:cs typeface="Calibri" pitchFamily="34" charset="-120"/>
+              </a:rPr>
+              <a:t>Can you write the cost using the letter n?</a:t>
+            </a:r>
+            <a:endParaRPr lang="en-US" sz="1400" dirty="0"/>
+          </a:p>
+          <a:p>
+            <a:pPr marL="342900" indent="-342900">
+              <a:spcAft>
+                <a:spcPts val="600"/>
+              </a:spcAft>
+              <a:buSzPct val="100000"/>
+              <a:buChar char="•"/>
+            </a:pPr>
+            <a:r>
+              <a:rPr lang="en-US" sz="1400" dirty="0">
+                <a:solidFill>
+                  <a:srgbClr val="E5E2DC"/>
+                </a:solidFill>
+                <a:latin typeface="Calibri" pitchFamily="34" charset="0"/>
+                <a:ea typeface="Calibri" pitchFamily="34" charset="-122"/>
+                <a:cs typeface="Calibri" pitchFamily="34" charset="-120"/>
+              </a:rPr>
+              <a:t>What if the base price changed to ¥3?</a:t>
+            </a:r>
+            <a:endParaRPr lang="en-US" sz="1400" dirty="0"/>
+          </a:p>
+          <a:p>
+            <a:pPr marL="342900" indent="-342900">
+              <a:spcAft>
+                <a:spcPts val="600"/>
+              </a:spcAft>
+              <a:buSzPct val="100000"/>
+              <a:buChar char="•"/>
+            </a:pPr>
+            <a:r>
+              <a:rPr lang="en-US" sz="1400" dirty="0">
+                <a:solidFill>
+                  <a:srgbClr val="E5E2DC"/>
+                </a:solidFill>
+                <a:latin typeface="Calibri" pitchFamily="34" charset="0"/>
+                <a:ea typeface="Calibri" pitchFamily="34" charset="-122"/>
+                <a:cs typeface="Calibri" pitchFamily="34" charset="-120"/>
+              </a:rPr>
+              <a:t>How is a rule different from a single calculation?</a:t>
+            </a:r>
+            <a:endParaRPr lang="en-US" sz="1400" dirty="0"/>
           </a:p>
         </p:txBody>
       </p:sp>
@@ -1655,7 +2181,27 @@
         <p:spPr>
           <a:xfrm>
             <a:off x="0" y="0"/>
-            <a:ext cx="9144000" cy="54864"/>
+            <a:ext cx="9144000" cy="822960"/>
+          </a:xfrm>
+          <a:prstGeom prst="rect">
+            <a:avLst/>
+          </a:prstGeom>
+          <a:solidFill>
+            <a:srgbClr val="FFFFFF"/>
+          </a:solidFill>
+          <a:ln/>
+        </p:spPr>
+      </p:sp>
+      <p:sp>
+        <p:nvSpPr>
+          <p:cNvPr id="3" name="Shape 1"/>
+          <p:cNvSpPr/>
+          <p:nvPr/>
+        </p:nvSpPr>
+        <p:spPr>
+          <a:xfrm>
+            <a:off x="0" y="795528"/>
+            <a:ext cx="9144000" cy="27432"/>
           </a:xfrm>
           <a:prstGeom prst="rect">
             <a:avLst/>
@@ -1668,14 +2214,14 @@
       </p:sp>
       <p:sp>
         <p:nvSpPr>
-          <p:cNvPr id="3" name="Text 1"/>
-          <p:cNvSpPr/>
-          <p:nvPr/>
-        </p:nvSpPr>
-        <p:spPr>
-          <a:xfrm>
-            <a:off x="7772400" y="4709160"/>
-            <a:ext cx="1097280" cy="320040"/>
+          <p:cNvPr id="4" name="Text 2"/>
+          <p:cNvSpPr/>
+          <p:nvPr/>
+        </p:nvSpPr>
+        <p:spPr>
+          <a:xfrm>
+            <a:off x="640080" y="91440"/>
+            <a:ext cx="7863840" cy="640080"/>
           </a:xfrm>
           <a:prstGeom prst="rect">
             <a:avLst/>
@@ -1684,53 +2230,14 @@
           <a:ln/>
         </p:spPr>
         <p:txBody>
-          <a:bodyPr wrap="square" rtlCol="0" anchor="ctr"/>
-          <a:lstStyle/>
-          <a:p>
-            <a:pPr algn="r" indent="0" marL="0">
-              <a:buNone/>
-            </a:pPr>
-            <a:r>
-              <a:rPr lang="en-US" sz="900" dirty="0">
-                <a:solidFill>
-                  <a:srgbClr val="6B6660"/>
-                </a:solidFill>
-                <a:latin typeface="Calibri" pitchFamily="34" charset="0"/>
-                <a:ea typeface="Calibri" pitchFamily="34" charset="-122"/>
-                <a:cs typeface="Calibri" pitchFamily="34" charset="-120"/>
-              </a:rPr>
-              <a:t>3 / 5</a:t>
-            </a:r>
-            <a:endParaRPr lang="en-US" sz="900" dirty="0"/>
-          </a:p>
-        </p:txBody>
-      </p:sp>
-      <p:sp>
-        <p:nvSpPr>
-          <p:cNvPr id="4" name="Text 2"/>
-          <p:cNvSpPr/>
-          <p:nvPr/>
-        </p:nvSpPr>
-        <p:spPr>
-          <a:xfrm>
-            <a:off x="457200" y="274320"/>
-            <a:ext cx="8229600" cy="640080"/>
-          </a:xfrm>
-          <a:prstGeom prst="rect">
-            <a:avLst/>
-          </a:prstGeom>
-          <a:noFill/>
-          <a:ln/>
-        </p:spPr>
-        <p:txBody>
-          <a:bodyPr wrap="square" rtlCol="0" anchor="ctr"/>
+          <a:bodyPr wrap="square" lIns="0" tIns="0" rIns="0" bIns="0" rtlCol="0" anchor="ctr"/>
           <a:lstStyle/>
           <a:p>
             <a:pPr indent="0" marL="0">
               <a:buNone/>
             </a:pPr>
             <a:r>
-              <a:rPr lang="en-US" sz="2600" b="1" dirty="0">
+              <a:rPr lang="en-US" sz="2200" b="1" dirty="0">
                 <a:solidFill>
                   <a:srgbClr val="1B2A4A"/>
                 </a:solidFill>
@@ -1738,9 +2245,9 @@
                 <a:ea typeface="Georgia" pitchFamily="34" charset="-122"/>
                 <a:cs typeface="Georgia" pitchFamily="34" charset="-120"/>
               </a:rPr>
-              <a:t>Translating Words to Algebra</a:t>
-            </a:r>
-            <a:endParaRPr lang="en-US" sz="2600" dirty="0"/>
+              <a:t>What Is an Expression?</a:t>
+            </a:r>
+            <a:endParaRPr lang="en-US" sz="2200" dirty="0"/>
           </a:p>
         </p:txBody>
       </p:sp>
@@ -1752,8 +2259,8 @@
         </p:nvSpPr>
         <p:spPr>
           <a:xfrm>
-            <a:off x="457200" y="1188720"/>
-            <a:ext cx="3840480" cy="3474720"/>
+            <a:off x="640080" y="1005840"/>
+            <a:ext cx="7863840" cy="2926080"/>
           </a:xfrm>
           <a:prstGeom prst="rect">
             <a:avLst/>
@@ -1762,18 +2269,18 @@
           <a:ln/>
         </p:spPr>
         <p:txBody>
-          <a:bodyPr wrap="square" rtlCol="0" anchor="t"/>
+          <a:bodyPr wrap="square" rtlCol="0" anchor="ctr"/>
           <a:lstStyle/>
           <a:p>
             <a:pPr marL="342900" indent="-342900">
               <a:spcAft>
-                <a:spcPts val="600"/>
+                <a:spcPts val="800"/>
               </a:spcAft>
               <a:buSzPct val="100000"/>
               <a:buChar char="•"/>
             </a:pPr>
             <a:r>
-              <a:rPr lang="en-US" sz="1400" dirty="0">
+              <a:rPr lang="en-US" sz="1600" dirty="0">
                 <a:solidFill>
                   <a:srgbClr val="3D3A36"/>
                 </a:solidFill>
@@ -1781,20 +2288,20 @@
                 <a:ea typeface="Calibri" pitchFamily="34" charset="-122"/>
                 <a:cs typeface="Calibri" pitchFamily="34" charset="-120"/>
               </a:rPr>
-              <a:t>'A number plus 3' → n + 3</a:t>
-            </a:r>
-            <a:endParaRPr lang="en-US" sz="1400" dirty="0"/>
+              <a:t>Uses numbers, letters (variables), and operations.</a:t>
+            </a:r>
+            <a:endParaRPr lang="en-US" sz="1600" dirty="0"/>
           </a:p>
           <a:p>
             <a:pPr marL="342900" indent="-342900">
               <a:spcAft>
-                <a:spcPts val="600"/>
+                <a:spcPts val="800"/>
               </a:spcAft>
               <a:buSzPct val="100000"/>
               <a:buChar char="•"/>
             </a:pPr>
             <a:r>
-              <a:rPr lang="en-US" sz="1400" dirty="0">
+              <a:rPr lang="en-US" sz="1600" dirty="0">
                 <a:solidFill>
                   <a:srgbClr val="3D3A36"/>
                 </a:solidFill>
@@ -1802,20 +2309,20 @@
                 <a:ea typeface="Calibri" pitchFamily="34" charset="-122"/>
                 <a:cs typeface="Calibri" pitchFamily="34" charset="-120"/>
               </a:rPr>
-              <a:t>'5 less than a number' → n − 5</a:t>
-            </a:r>
-            <a:endParaRPr lang="en-US" sz="1400" dirty="0"/>
+              <a:t>Does NOT have an equals sign (that's an equation).</a:t>
+            </a:r>
+            <a:endParaRPr lang="en-US" sz="1600" dirty="0"/>
           </a:p>
           <a:p>
             <a:pPr marL="342900" indent="-342900">
               <a:spcAft>
-                <a:spcPts val="600"/>
+                <a:spcPts val="800"/>
               </a:spcAft>
               <a:buSzPct val="100000"/>
               <a:buChar char="•"/>
             </a:pPr>
             <a:r>
-              <a:rPr lang="en-US" sz="1400" dirty="0">
+              <a:rPr lang="en-US" sz="1600" dirty="0">
                 <a:solidFill>
                   <a:srgbClr val="3D3A36"/>
                 </a:solidFill>
@@ -1823,20 +2330,20 @@
                 <a:ea typeface="Calibri" pitchFamily="34" charset="-122"/>
                 <a:cs typeface="Calibri" pitchFamily="34" charset="-120"/>
               </a:rPr>
-              <a:t>'Double a number' → 2n (means 2 × n)</a:t>
-            </a:r>
-            <a:endParaRPr lang="en-US" sz="1400" dirty="0"/>
+              <a:t>Examples: 3x + 5, 2a − 7, 4n².</a:t>
+            </a:r>
+            <a:endParaRPr lang="en-US" sz="1600" dirty="0"/>
           </a:p>
           <a:p>
             <a:pPr marL="342900" indent="-342900">
               <a:spcAft>
-                <a:spcPts val="600"/>
+                <a:spcPts val="800"/>
               </a:spcAft>
               <a:buSzPct val="100000"/>
               <a:buChar char="•"/>
             </a:pPr>
             <a:r>
-              <a:rPr lang="en-US" sz="1400" dirty="0">
+              <a:rPr lang="en-US" sz="1600" dirty="0">
                 <a:solidFill>
                   <a:srgbClr val="3D3A36"/>
                 </a:solidFill>
@@ -1844,20 +2351,85 @@
                 <a:ea typeface="Calibri" pitchFamily="34" charset="-122"/>
                 <a:cs typeface="Calibri" pitchFamily="34" charset="-120"/>
               </a:rPr>
-              <a:t>'A number divided by 4' → n/4 or n ÷ 4</a:t>
-            </a:r>
-            <a:endParaRPr lang="en-US" sz="1400" dirty="0"/>
-          </a:p>
-          <a:p>
-            <a:pPr marL="342900" indent="-342900">
-              <a:spcAft>
-                <a:spcPts val="600"/>
-              </a:spcAft>
-              <a:buSzPct val="100000"/>
-              <a:buChar char="•"/>
+              <a:t>The letter represents a number we don't know yet.</a:t>
+            </a:r>
+            <a:endParaRPr lang="en-US" sz="1600" dirty="0"/>
+          </a:p>
+        </p:txBody>
+      </p:sp>
+      <p:sp>
+        <p:nvSpPr>
+          <p:cNvPr id="6" name="Shape 4"/>
+          <p:cNvSpPr/>
+          <p:nvPr/>
+        </p:nvSpPr>
+        <p:spPr>
+          <a:xfrm>
+            <a:off x="640080" y="4114800"/>
+            <a:ext cx="7863840" cy="731520"/>
+          </a:xfrm>
+          <a:prstGeom prst="rect">
+            <a:avLst/>
+          </a:prstGeom>
+          <a:solidFill>
+            <a:srgbClr val="E8F5F3"/>
+          </a:solidFill>
+          <a:ln/>
+          <a:effectLst>
+            <a:outerShdw sx="100000" sy="100000" kx="0" ky="0" algn="bl" rotWithShape="0" blurRad="76200" dist="25400" dir="8100000">
+              <a:srgbClr val="000000">
+                <a:alpha val="12000"/>
+              </a:srgbClr>
+            </a:outerShdw>
+          </a:effectLst>
+        </p:spPr>
+      </p:sp>
+      <p:sp>
+        <p:nvSpPr>
+          <p:cNvPr id="7" name="Shape 5"/>
+          <p:cNvSpPr/>
+          <p:nvPr/>
+        </p:nvSpPr>
+        <p:spPr>
+          <a:xfrm>
+            <a:off x="640080" y="4114800"/>
+            <a:ext cx="64008" cy="731520"/>
+          </a:xfrm>
+          <a:prstGeom prst="rect">
+            <a:avLst/>
+          </a:prstGeom>
+          <a:solidFill>
+            <a:srgbClr val="2A9D8F"/>
+          </a:solidFill>
+          <a:ln/>
+        </p:spPr>
+      </p:sp>
+      <p:sp>
+        <p:nvSpPr>
+          <p:cNvPr id="8" name="Text 6"/>
+          <p:cNvSpPr/>
+          <p:nvPr/>
+        </p:nvSpPr>
+        <p:spPr>
+          <a:xfrm>
+            <a:off x="914400" y="4160520"/>
+            <a:ext cx="7406640" cy="640080"/>
+          </a:xfrm>
+          <a:prstGeom prst="rect">
+            <a:avLst/>
+          </a:prstGeom>
+          <a:noFill/>
+          <a:ln/>
+        </p:spPr>
+        <p:txBody>
+          <a:bodyPr wrap="square" rtlCol="0" anchor="ctr"/>
+          <a:lstStyle/>
+          <a:p>
+            <a:pPr indent="0" marL="0">
+              <a:buNone/>
             </a:pPr>
             <a:r>
-              <a:rPr lang="en-US" sz="1400" dirty="0">
+              <a:rPr lang="en-US" sz="1300" i="1" dirty="0">
                 <a:solidFill>
                   <a:srgbClr val="3D3A36"/>
                 </a:solidFill>
@@ -1865,233 +2437,9 @@
                 <a:ea typeface="Calibri" pitchFamily="34" charset="-122"/>
                 <a:cs typeface="Calibri" pitchFamily="34" charset="-120"/>
               </a:rPr>
-              <a:t>'3 more than twice a number' → 2n + 3</a:t>
-            </a:r>
-            <a:endParaRPr lang="en-US" sz="1400" dirty="0"/>
-          </a:p>
-          <a:p>
-            <a:pPr marL="342900" indent="-342900">
-              <a:spcAft>
-                <a:spcPts val="600"/>
-              </a:spcAft>
-              <a:buSzPct val="100000"/>
-              <a:buChar char="•"/>
-            </a:pPr>
-            <a:r>
-              <a:rPr lang="en-US" sz="1400" dirty="0">
-                <a:solidFill>
-                  <a:srgbClr val="3D3A36"/>
-                </a:solidFill>
-                <a:latin typeface="Calibri" pitchFamily="34" charset="0"/>
-                <a:ea typeface="Calibri" pitchFamily="34" charset="-122"/>
-                <a:cs typeface="Calibri" pitchFamily="34" charset="-120"/>
-              </a:rPr>
-              <a:t>In algebra, we write 2n not 2 × n (no × sign)</a:t>
-            </a:r>
-            <a:endParaRPr lang="en-US" sz="1400" dirty="0"/>
-          </a:p>
-        </p:txBody>
-      </p:sp>
-      <p:sp>
-        <p:nvSpPr>
-          <p:cNvPr id="6" name="Shape 4"/>
-          <p:cNvSpPr/>
-          <p:nvPr/>
-        </p:nvSpPr>
-        <p:spPr>
-          <a:xfrm>
-            <a:off x="4846320" y="1188720"/>
-            <a:ext cx="3840480" cy="3474720"/>
-          </a:xfrm>
-          <a:prstGeom prst="rect">
-            <a:avLst/>
-          </a:prstGeom>
-          <a:solidFill>
-            <a:srgbClr val="FFFFFF"/>
-          </a:solidFill>
-          <a:ln w="12700">
-            <a:solidFill>
-              <a:srgbClr val="E5E2DC"/>
-            </a:solidFill>
-            <a:prstDash val="solid"/>
-          </a:ln>
-          <a:effectLst>
-            <a:outerShdw sx="100000" sy="100000" kx="0" ky="0" algn="bl" rotWithShape="0" blurRad="50800" dist="25400" dir="8100000">
-              <a:srgbClr val="000000">
-                <a:alpha val="10000"/>
-              </a:srgbClr>
-            </a:outerShdw>
-          </a:effectLst>
-        </p:spPr>
-      </p:sp>
-      <p:sp>
-        <p:nvSpPr>
-          <p:cNvPr id="7" name="Shape 5"/>
-          <p:cNvSpPr/>
-          <p:nvPr/>
-        </p:nvSpPr>
-        <p:spPr>
-          <a:xfrm>
-            <a:off x="4846320" y="1188720"/>
-            <a:ext cx="3840480" cy="54864"/>
-          </a:xfrm>
-          <a:prstGeom prst="rect">
-            <a:avLst/>
-          </a:prstGeom>
-          <a:solidFill>
-            <a:srgbClr val="2A9D8F"/>
-          </a:solidFill>
-          <a:ln/>
-        </p:spPr>
-      </p:sp>
-      <p:sp>
-        <p:nvSpPr>
-          <p:cNvPr id="8" name="Text 6"/>
-          <p:cNvSpPr/>
-          <p:nvPr/>
-        </p:nvSpPr>
-        <p:spPr>
-          <a:xfrm>
-            <a:off x="5120640" y="1371600"/>
-            <a:ext cx="3291840" cy="3108960"/>
-          </a:xfrm>
-          <a:prstGeom prst="rect">
-            <a:avLst/>
-          </a:prstGeom>
-          <a:noFill/>
-          <a:ln/>
-        </p:spPr>
-        <p:txBody>
-          <a:bodyPr wrap="square" rtlCol="0" anchor="t"/>
-          <a:lstStyle/>
-          <a:p>
-            <a:pPr indent="0" marL="0">
-              <a:spcAft>
-                <a:spcPts val="400"/>
-              </a:spcAft>
-              <a:buNone/>
-            </a:pPr>
-            <a:r>
-              <a:rPr lang="en-US" sz="1600" b="1" dirty="0">
-                <a:solidFill>
-                  <a:srgbClr val="1B2A4A"/>
-                </a:solidFill>
-                <a:latin typeface="Calibri" pitchFamily="34" charset="0"/>
-                <a:ea typeface="Calibri" pitchFamily="34" charset="-122"/>
-                <a:cs typeface="Calibri" pitchFamily="34" charset="-120"/>
-              </a:rPr>
-              <a:t>Key Rules</a:t>
-            </a:r>
-            <a:endParaRPr lang="en-US" sz="1600" dirty="0"/>
-          </a:p>
-          <a:p>
-            <a:pPr indent="0" marL="0">
-              <a:spcAft>
-                <a:spcPts val="400"/>
-              </a:spcAft>
-              <a:buNone/>
-            </a:pPr>
-            <a:endParaRPr lang="en-US" sz="1600" dirty="0"/>
-          </a:p>
-          <a:p>
-            <a:pPr indent="0" marL="0">
-              <a:spcAft>
-                <a:spcPts val="400"/>
-              </a:spcAft>
-              <a:buNone/>
-            </a:pPr>
-            <a:r>
-              <a:rPr lang="en-US" sz="1300" dirty="0">
-                <a:solidFill>
-                  <a:srgbClr val="3D3A36"/>
-                </a:solidFill>
-                <a:latin typeface="Calibri" pitchFamily="34" charset="0"/>
-                <a:ea typeface="Calibri" pitchFamily="34" charset="-122"/>
-                <a:cs typeface="Calibri" pitchFamily="34" charset="-120"/>
-              </a:rPr>
-              <a:t>We don't write the × sign: 3 × x = 3x</a:t>
-            </a:r>
-            <a:endParaRPr lang="en-US" sz="1600" dirty="0"/>
-          </a:p>
-          <a:p>
-            <a:pPr indent="0" marL="0">
-              <a:spcAft>
-                <a:spcPts val="400"/>
-              </a:spcAft>
-              <a:buNone/>
-            </a:pPr>
-            <a:r>
-              <a:rPr lang="en-US" sz="1300" dirty="0">
-                <a:solidFill>
-                  <a:srgbClr val="3D3A36"/>
-                </a:solidFill>
-                <a:latin typeface="Calibri" pitchFamily="34" charset="0"/>
-                <a:ea typeface="Calibri" pitchFamily="34" charset="-122"/>
-                <a:cs typeface="Calibri" pitchFamily="34" charset="-120"/>
-              </a:rPr>
-              <a:t>The number goes BEFORE the letter: 3x not x3</a:t>
-            </a:r>
-            <a:endParaRPr lang="en-US" sz="1600" dirty="0"/>
-          </a:p>
-          <a:p>
-            <a:pPr indent="0" marL="0">
-              <a:spcAft>
-                <a:spcPts val="400"/>
-              </a:spcAft>
-              <a:buNone/>
-            </a:pPr>
-            <a:r>
-              <a:rPr lang="en-US" sz="1300" dirty="0">
-                <a:solidFill>
-                  <a:srgbClr val="3D3A36"/>
-                </a:solidFill>
-                <a:latin typeface="Calibri" pitchFamily="34" charset="0"/>
-                <a:ea typeface="Calibri" pitchFamily="34" charset="-122"/>
-                <a:cs typeface="Calibri" pitchFamily="34" charset="-120"/>
-              </a:rPr>
-              <a:t>1x is just written as x</a:t>
-            </a:r>
-            <a:endParaRPr lang="en-US" sz="1600" dirty="0"/>
-          </a:p>
-          <a:p>
-            <a:pPr indent="0" marL="0">
-              <a:spcAft>
-                <a:spcPts val="400"/>
-              </a:spcAft>
-              <a:buNone/>
-            </a:pPr>
-            <a:r>
-              <a:rPr lang="en-US" sz="1300" dirty="0">
-                <a:solidFill>
-                  <a:srgbClr val="3D3A36"/>
-                </a:solidFill>
-                <a:latin typeface="Calibri" pitchFamily="34" charset="0"/>
-                <a:ea typeface="Calibri" pitchFamily="34" charset="-122"/>
-                <a:cs typeface="Calibri" pitchFamily="34" charset="-120"/>
-              </a:rPr>
-              <a:t>x × x = x² (x squared)</a:t>
-            </a:r>
-            <a:endParaRPr lang="en-US" sz="1600" dirty="0"/>
-          </a:p>
-          <a:p>
-            <a:pPr indent="0" marL="0">
-              <a:spcAft>
-                <a:spcPts val="400"/>
-              </a:spcAft>
-              <a:buNone/>
-            </a:pPr>
-            <a:r>
-              <a:rPr lang="en-US" sz="1300" dirty="0">
-                <a:solidFill>
-                  <a:srgbClr val="3D3A36"/>
-                </a:solidFill>
-                <a:latin typeface="Calibri" pitchFamily="34" charset="0"/>
-                <a:ea typeface="Calibri" pitchFamily="34" charset="-122"/>
-                <a:cs typeface="Calibri" pitchFamily="34" charset="-120"/>
-              </a:rPr>
-              <a:t>Always use the same letter if it represents the same unknown</a:t>
-            </a:r>
-            <a:endParaRPr lang="en-US" sz="1600" dirty="0"/>
+              <a:t>Expression = no equals sign. Equation = has an equals sign.</a:t>
+            </a:r>
+            <a:endParaRPr lang="en-US" sz="1300" dirty="0"/>
           </a:p>
         </p:txBody>
       </p:sp>
@@ -2136,7 +2484,27 @@
         <p:spPr>
           <a:xfrm>
             <a:off x="0" y="0"/>
-            <a:ext cx="9144000" cy="54864"/>
+            <a:ext cx="9144000" cy="822960"/>
+          </a:xfrm>
+          <a:prstGeom prst="rect">
+            <a:avLst/>
+          </a:prstGeom>
+          <a:solidFill>
+            <a:srgbClr val="FFFFFF"/>
+          </a:solidFill>
+          <a:ln/>
+        </p:spPr>
+      </p:sp>
+      <p:sp>
+        <p:nvSpPr>
+          <p:cNvPr id="3" name="Shape 1"/>
+          <p:cNvSpPr/>
+          <p:nvPr/>
+        </p:nvSpPr>
+        <p:spPr>
+          <a:xfrm>
+            <a:off x="0" y="795528"/>
+            <a:ext cx="9144000" cy="27432"/>
           </a:xfrm>
           <a:prstGeom prst="rect">
             <a:avLst/>
@@ -2149,14 +2517,14 @@
       </p:sp>
       <p:sp>
         <p:nvSpPr>
-          <p:cNvPr id="3" name="Text 1"/>
-          <p:cNvSpPr/>
-          <p:nvPr/>
-        </p:nvSpPr>
-        <p:spPr>
-          <a:xfrm>
-            <a:off x="7772400" y="4709160"/>
-            <a:ext cx="1097280" cy="320040"/>
+          <p:cNvPr id="4" name="Text 2"/>
+          <p:cNvSpPr/>
+          <p:nvPr/>
+        </p:nvSpPr>
+        <p:spPr>
+          <a:xfrm>
+            <a:off x="640080" y="91440"/>
+            <a:ext cx="7863840" cy="640080"/>
           </a:xfrm>
           <a:prstGeom prst="rect">
             <a:avLst/>
@@ -2165,53 +2533,14 @@
           <a:ln/>
         </p:spPr>
         <p:txBody>
-          <a:bodyPr wrap="square" rtlCol="0" anchor="ctr"/>
-          <a:lstStyle/>
-          <a:p>
-            <a:pPr algn="r" indent="0" marL="0">
-              <a:buNone/>
-            </a:pPr>
-            <a:r>
-              <a:rPr lang="en-US" sz="900" dirty="0">
-                <a:solidFill>
-                  <a:srgbClr val="6B6660"/>
-                </a:solidFill>
-                <a:latin typeface="Calibri" pitchFamily="34" charset="0"/>
-                <a:ea typeface="Calibri" pitchFamily="34" charset="-122"/>
-                <a:cs typeface="Calibri" pitchFamily="34" charset="-120"/>
-              </a:rPr>
-              <a:t>4 / 5</a:t>
-            </a:r>
-            <a:endParaRPr lang="en-US" sz="900" dirty="0"/>
-          </a:p>
-        </p:txBody>
-      </p:sp>
-      <p:sp>
-        <p:nvSpPr>
-          <p:cNvPr id="4" name="Text 2"/>
-          <p:cNvSpPr/>
-          <p:nvPr/>
-        </p:nvSpPr>
-        <p:spPr>
-          <a:xfrm>
-            <a:off x="457200" y="274320"/>
-            <a:ext cx="8229600" cy="640080"/>
-          </a:xfrm>
-          <a:prstGeom prst="rect">
-            <a:avLst/>
-          </a:prstGeom>
-          <a:noFill/>
-          <a:ln/>
-        </p:spPr>
-        <p:txBody>
-          <a:bodyPr wrap="square" rtlCol="0" anchor="ctr"/>
+          <a:bodyPr wrap="square" lIns="0" tIns="0" rIns="0" bIns="0" rtlCol="0" anchor="ctr"/>
           <a:lstStyle/>
           <a:p>
             <a:pPr indent="0" marL="0">
               <a:buNone/>
             </a:pPr>
             <a:r>
-              <a:rPr lang="en-US" sz="2600" b="1" dirty="0">
+              <a:rPr lang="en-US" sz="2200" b="1" dirty="0">
                 <a:solidFill>
                   <a:srgbClr val="1B2A4A"/>
                 </a:solidFill>
@@ -2219,160 +2548,708 @@
                 <a:ea typeface="Georgia" pitchFamily="34" charset="-122"/>
                 <a:cs typeface="Georgia" pitchFamily="34" charset="-120"/>
               </a:rPr>
-              <a:t>Simplifying Expressions</a:t>
-            </a:r>
-            <a:endParaRPr lang="en-US" sz="2600" dirty="0"/>
-          </a:p>
-        </p:txBody>
-      </p:sp>
-      <p:sp>
-        <p:nvSpPr>
-          <p:cNvPr id="5" name="Text 3"/>
-          <p:cNvSpPr/>
-          <p:nvPr/>
-        </p:nvSpPr>
-        <p:spPr>
-          <a:xfrm>
-            <a:off x="457200" y="1097280"/>
-            <a:ext cx="8229600" cy="3657600"/>
-          </a:xfrm>
-          <a:prstGeom prst="rect">
-            <a:avLst/>
-          </a:prstGeom>
-          <a:noFill/>
-          <a:ln/>
-        </p:spPr>
-        <p:txBody>
-          <a:bodyPr wrap="square" rtlCol="0" anchor="t"/>
-          <a:lstStyle/>
-          <a:p>
-            <a:pPr marL="342900" indent="-342900">
-              <a:spcAft>
-                <a:spcPts val="800"/>
-              </a:spcAft>
-              <a:buSzPct val="100000"/>
-              <a:buChar char="•"/>
-            </a:pPr>
-            <a:r>
-              <a:rPr lang="en-US" sz="1400" dirty="0">
-                <a:solidFill>
-                  <a:srgbClr val="3D3A36"/>
-                </a:solidFill>
-                <a:latin typeface="Calibri" pitchFamily="34" charset="0"/>
-                <a:ea typeface="Calibri" pitchFamily="34" charset="-122"/>
-                <a:cs typeface="Calibri" pitchFamily="34" charset="-120"/>
-              </a:rPr>
-              <a:t>Like terms have the SAME letter: 3x and 5x are like terms</a:t>
-            </a:r>
-            <a:endParaRPr lang="en-US" sz="1400" dirty="0"/>
-          </a:p>
-          <a:p>
-            <a:pPr marL="342900" indent="-342900">
-              <a:spcAft>
-                <a:spcPts val="800"/>
-              </a:spcAft>
-              <a:buSzPct val="100000"/>
-              <a:buChar char="•"/>
-            </a:pPr>
-            <a:r>
-              <a:rPr lang="en-US" sz="1400" dirty="0">
-                <a:solidFill>
-                  <a:srgbClr val="3D3A36"/>
-                </a:solidFill>
-                <a:latin typeface="Calibri" pitchFamily="34" charset="0"/>
-                <a:ea typeface="Calibri" pitchFamily="34" charset="-122"/>
-                <a:cs typeface="Calibri" pitchFamily="34" charset="-120"/>
-              </a:rPr>
-              <a:t>3x + 5x = 8x (add the coefficients)</a:t>
-            </a:r>
-            <a:endParaRPr lang="en-US" sz="1400" dirty="0"/>
-          </a:p>
-          <a:p>
-            <a:pPr marL="342900" indent="-342900">
-              <a:spcAft>
-                <a:spcPts val="800"/>
-              </a:spcAft>
-              <a:buSzPct val="100000"/>
-              <a:buChar char="•"/>
-            </a:pPr>
-            <a:r>
-              <a:rPr lang="en-US" sz="1400" dirty="0">
-                <a:solidFill>
-                  <a:srgbClr val="3D3A36"/>
-                </a:solidFill>
-                <a:latin typeface="Calibri" pitchFamily="34" charset="0"/>
-                <a:ea typeface="Calibri" pitchFamily="34" charset="-122"/>
-                <a:cs typeface="Calibri" pitchFamily="34" charset="-120"/>
-              </a:rPr>
-              <a:t>4a + 2b + a = 5a + 2b (combine like terms)</a:t>
-            </a:r>
-            <a:endParaRPr lang="en-US" sz="1400" dirty="0"/>
-          </a:p>
-          <a:p>
-            <a:pPr marL="342900" indent="-342900">
-              <a:spcAft>
-                <a:spcPts val="800"/>
-              </a:spcAft>
-              <a:buSzPct val="100000"/>
-              <a:buChar char="•"/>
-            </a:pPr>
-            <a:r>
-              <a:rPr lang="en-US" sz="1400" dirty="0">
-                <a:solidFill>
-                  <a:srgbClr val="3D3A36"/>
-                </a:solidFill>
-                <a:latin typeface="Calibri" pitchFamily="34" charset="0"/>
-                <a:ea typeface="Calibri" pitchFamily="34" charset="-122"/>
-                <a:cs typeface="Calibri" pitchFamily="34" charset="-120"/>
-              </a:rPr>
-              <a:t>3x + 2y − x + 4y = 2x + 6y</a:t>
-            </a:r>
-            <a:endParaRPr lang="en-US" sz="1400" dirty="0"/>
-          </a:p>
-          <a:p>
-            <a:pPr marL="342900" indent="-342900">
-              <a:spcAft>
-                <a:spcPts val="800"/>
-              </a:spcAft>
-              <a:buSzPct val="100000"/>
-              <a:buChar char="•"/>
-            </a:pPr>
-            <a:r>
-              <a:rPr lang="en-US" sz="1400" dirty="0">
-                <a:solidFill>
-                  <a:srgbClr val="3D3A36"/>
-                </a:solidFill>
-                <a:latin typeface="Calibri" pitchFamily="34" charset="0"/>
-                <a:ea typeface="Calibri" pitchFamily="34" charset="-122"/>
-                <a:cs typeface="Calibri" pitchFamily="34" charset="-120"/>
-              </a:rPr>
-              <a:t>You CANNOT simplify 3x + 2y further (different letters)</a:t>
-            </a:r>
-            <a:endParaRPr lang="en-US" sz="1400" dirty="0"/>
-          </a:p>
-          <a:p>
-            <a:pPr marL="342900" indent="-342900">
-              <a:spcAft>
-                <a:spcPts val="800"/>
-              </a:spcAft>
-              <a:buSzPct val="100000"/>
-              <a:buChar char="•"/>
-            </a:pPr>
-            <a:r>
-              <a:rPr lang="en-US" sz="1400" dirty="0">
-                <a:solidFill>
-                  <a:srgbClr val="3D3A36"/>
-                </a:solidFill>
-                <a:latin typeface="Calibri" pitchFamily="34" charset="0"/>
-                <a:ea typeface="Calibri" pitchFamily="34" charset="-122"/>
-                <a:cs typeface="Calibri" pitchFamily="34" charset="-120"/>
-              </a:rPr>
-              <a:t>Coefficient = the number in front of the letter</a:t>
-            </a:r>
-            <a:endParaRPr lang="en-US" sz="1400" dirty="0"/>
-          </a:p>
-        </p:txBody>
-      </p:sp>
+              <a:t>Key Vocabulary</a:t>
+            </a:r>
+            <a:endParaRPr lang="en-US" sz="2200" dirty="0"/>
+          </a:p>
+        </p:txBody>
+      </p:sp>
+      <p:graphicFrame>
+        <p:nvGraphicFramePr>
+          <p:cNvPr id="5" name="Table 0"/>
+          <p:cNvGraphicFramePr>
+            <a:graphicFrameLocks noGrp="1"/>
+          </p:cNvGraphicFramePr>
+          <p:nvPr>
+            <p:extLst>
+              <p:ext uri="{D42A27DB-BD31-4B8C-83A1-F6EECF244321}">
+                <p14:modId xmlns:p14="http://schemas.microsoft.com/office/powerpoint/2010/main" val="1579011935"/>
+              </p:ext>
+            </p:extLst>
+          </p:nvPr>
+        </p:nvGraphicFramePr>
+        <p:xfrm>
+          <a:off x="640080" y="1005840"/>
+          <a:ext cx="7863840" cy="914400"/>
+        </p:xfrm>
+        <a:graphic>
+          <a:graphicData uri="http://schemas.openxmlformats.org/drawingml/2006/table">
+            <a:tbl>
+              <a:tblPr/>
+              <a:tblGrid>
+                <a:gridCol w="2286000"/>
+                <a:gridCol w="5577840"/>
+              </a:tblGrid>
+              <a:tr h="457200">
+                <a:tc>
+                  <a:txBody>
+                    <a:bodyPr/>
+                    <a:lstStyle/>
+                    <a:p>
+                      <a:pPr indent="0" marL="0">
+                        <a:buNone/>
+                      </a:pPr>
+                      <a:r>
+                        <a:rPr lang="en-US" sz="1300" b="1" dirty="0">
+                          <a:solidFill>
+                            <a:srgbClr val="FFFFFF"/>
+                          </a:solidFill>
+                          <a:latin typeface="Calibri" pitchFamily="34" charset="0"/>
+                          <a:ea typeface="Calibri" pitchFamily="34" charset="-122"/>
+                          <a:cs typeface="Calibri" pitchFamily="34" charset="-120"/>
+                        </a:rPr>
+                        <a:t>Term</a:t>
+                      </a:r>
+                      <a:endParaRPr lang="en-US" sz="1300" dirty="0">
+                        <a:latin typeface="Calibri" charset="0"/>
+                        <a:ea typeface="Calibri" charset="0"/>
+                        <a:cs typeface="Calibri" charset="0"/>
+                      </a:endParaRPr>
+                    </a:p>
+                  </a:txBody>
+                  <a:tcPr marL="91440" marR="91440" marT="45720" marB="45720">
+                    <a:lnL w="6350" cap="flat" cmpd="sng" algn="ctr">
+                      <a:solidFill>
+                        <a:srgbClr val="E5E2DC"/>
+                      </a:solidFill>
+                      <a:prstDash val="solid"/>
+                      <a:round/>
+                      <a:headEnd type="none" w="med" len="med"/>
+                      <a:tailEnd type="none" w="med" len="med"/>
+                    </a:lnL>
+                    <a:lnR w="6350" cap="flat" cmpd="sng" algn="ctr">
+                      <a:solidFill>
+                        <a:srgbClr val="E5E2DC"/>
+                      </a:solidFill>
+                      <a:prstDash val="solid"/>
+                      <a:round/>
+                      <a:headEnd type="none" w="med" len="med"/>
+                      <a:tailEnd type="none" w="med" len="med"/>
+                    </a:lnR>
+                    <a:lnT w="6350" cap="flat" cmpd="sng" algn="ctr">
+                      <a:solidFill>
+                        <a:srgbClr val="E5E2DC"/>
+                      </a:solidFill>
+                      <a:prstDash val="solid"/>
+                      <a:round/>
+                      <a:headEnd type="none" w="med" len="med"/>
+                      <a:tailEnd type="none" w="med" len="med"/>
+                    </a:lnT>
+                    <a:lnB w="6350" cap="flat" cmpd="sng" algn="ctr">
+                      <a:solidFill>
+                        <a:srgbClr val="E5E2DC"/>
+                      </a:solidFill>
+                      <a:prstDash val="solid"/>
+                      <a:round/>
+                      <a:headEnd type="none" w="med" len="med"/>
+                      <a:tailEnd type="none" w="med" len="med"/>
+                    </a:lnB>
+                    <a:solidFill>
+                      <a:srgbClr val="2A9D8F"/>
+                    </a:solidFill>
+                  </a:tcPr>
+                </a:tc>
+                <a:tc>
+                  <a:txBody>
+                    <a:bodyPr/>
+                    <a:lstStyle/>
+                    <a:p>
+                      <a:pPr indent="0" marL="0">
+                        <a:buNone/>
+                      </a:pPr>
+                      <a:r>
+                        <a:rPr lang="en-US" sz="1300" b="1" dirty="0">
+                          <a:solidFill>
+                            <a:srgbClr val="FFFFFF"/>
+                          </a:solidFill>
+                          <a:latin typeface="Calibri" pitchFamily="34" charset="0"/>
+                          <a:ea typeface="Calibri" pitchFamily="34" charset="-122"/>
+                          <a:cs typeface="Calibri" pitchFamily="34" charset="-120"/>
+                        </a:rPr>
+                        <a:t>Definition</a:t>
+                      </a:r>
+                      <a:endParaRPr lang="en-US" sz="1300" dirty="0">
+                        <a:latin typeface="Calibri" charset="0"/>
+                        <a:ea typeface="Calibri" charset="0"/>
+                        <a:cs typeface="Calibri" charset="0"/>
+                      </a:endParaRPr>
+                    </a:p>
+                  </a:txBody>
+                  <a:tcPr marL="91440" marR="91440" marT="45720" marB="45720">
+                    <a:lnL w="6350" cap="flat" cmpd="sng" algn="ctr">
+                      <a:solidFill>
+                        <a:srgbClr val="E5E2DC"/>
+                      </a:solidFill>
+                      <a:prstDash val="solid"/>
+                      <a:round/>
+                      <a:headEnd type="none" w="med" len="med"/>
+                      <a:tailEnd type="none" w="med" len="med"/>
+                    </a:lnL>
+                    <a:lnR w="6350" cap="flat" cmpd="sng" algn="ctr">
+                      <a:solidFill>
+                        <a:srgbClr val="E5E2DC"/>
+                      </a:solidFill>
+                      <a:prstDash val="solid"/>
+                      <a:round/>
+                      <a:headEnd type="none" w="med" len="med"/>
+                      <a:tailEnd type="none" w="med" len="med"/>
+                    </a:lnR>
+                    <a:lnT w="6350" cap="flat" cmpd="sng" algn="ctr">
+                      <a:solidFill>
+                        <a:srgbClr val="E5E2DC"/>
+                      </a:solidFill>
+                      <a:prstDash val="solid"/>
+                      <a:round/>
+                      <a:headEnd type="none" w="med" len="med"/>
+                      <a:tailEnd type="none" w="med" len="med"/>
+                    </a:lnT>
+                    <a:lnB w="6350" cap="flat" cmpd="sng" algn="ctr">
+                      <a:solidFill>
+                        <a:srgbClr val="E5E2DC"/>
+                      </a:solidFill>
+                      <a:prstDash val="solid"/>
+                      <a:round/>
+                      <a:headEnd type="none" w="med" len="med"/>
+                      <a:tailEnd type="none" w="med" len="med"/>
+                    </a:lnB>
+                    <a:solidFill>
+                      <a:srgbClr val="2A9D8F"/>
+                    </a:solidFill>
+                  </a:tcPr>
+                </a:tc>
+              </a:tr>
+              <a:tr h="457200">
+                <a:tc>
+                  <a:txBody>
+                    <a:bodyPr/>
+                    <a:lstStyle/>
+                    <a:p>
+                      <a:pPr indent="0" marL="0">
+                        <a:buNone/>
+                      </a:pPr>
+                      <a:r>
+                        <a:rPr lang="en-US" sz="1400" b="1" dirty="0">
+                          <a:solidFill>
+                            <a:srgbClr val="1B2A4A"/>
+                          </a:solidFill>
+                          <a:latin typeface="Calibri" pitchFamily="34" charset="0"/>
+                          <a:ea typeface="Calibri" pitchFamily="34" charset="-122"/>
+                          <a:cs typeface="Calibri" pitchFamily="34" charset="-120"/>
+                        </a:rPr>
+                        <a:t>Variable</a:t>
+                      </a:r>
+                      <a:endParaRPr lang="en-US" sz="1400" dirty="0">
+                        <a:latin typeface="Calibri" charset="0"/>
+                        <a:ea typeface="Calibri" charset="0"/>
+                        <a:cs typeface="Calibri" charset="0"/>
+                      </a:endParaRPr>
+                    </a:p>
+                  </a:txBody>
+                  <a:tcPr marL="91440" marR="91440" marT="45720" marB="45720">
+                    <a:lnL w="6350" cap="flat" cmpd="sng" algn="ctr">
+                      <a:solidFill>
+                        <a:srgbClr val="E5E2DC"/>
+                      </a:solidFill>
+                      <a:prstDash val="solid"/>
+                      <a:round/>
+                      <a:headEnd type="none" w="med" len="med"/>
+                      <a:tailEnd type="none" w="med" len="med"/>
+                    </a:lnL>
+                    <a:lnR w="6350" cap="flat" cmpd="sng" algn="ctr">
+                      <a:solidFill>
+                        <a:srgbClr val="E5E2DC"/>
+                      </a:solidFill>
+                      <a:prstDash val="solid"/>
+                      <a:round/>
+                      <a:headEnd type="none" w="med" len="med"/>
+                      <a:tailEnd type="none" w="med" len="med"/>
+                    </a:lnR>
+                    <a:lnT w="6350" cap="flat" cmpd="sng" algn="ctr">
+                      <a:solidFill>
+                        <a:srgbClr val="E5E2DC"/>
+                      </a:solidFill>
+                      <a:prstDash val="solid"/>
+                      <a:round/>
+                      <a:headEnd type="none" w="med" len="med"/>
+                      <a:tailEnd type="none" w="med" len="med"/>
+                    </a:lnT>
+                    <a:lnB w="6350" cap="flat" cmpd="sng" algn="ctr">
+                      <a:solidFill>
+                        <a:srgbClr val="E5E2DC"/>
+                      </a:solidFill>
+                      <a:prstDash val="solid"/>
+                      <a:round/>
+                      <a:headEnd type="none" w="med" len="med"/>
+                      <a:tailEnd type="none" w="med" len="med"/>
+                    </a:lnB>
+                  </a:tcPr>
+                </a:tc>
+                <a:tc>
+                  <a:txBody>
+                    <a:bodyPr/>
+                    <a:lstStyle/>
+                    <a:p>
+                      <a:pPr indent="0" marL="0">
+                        <a:buNone/>
+                      </a:pPr>
+                      <a:r>
+                        <a:rPr lang="en-US" sz="1400" dirty="0">
+                          <a:solidFill>
+                            <a:srgbClr val="3D3A36"/>
+                          </a:solidFill>
+                          <a:latin typeface="Calibri" pitchFamily="34" charset="0"/>
+                          <a:ea typeface="Calibri" pitchFamily="34" charset="-122"/>
+                          <a:cs typeface="Calibri" pitchFamily="34" charset="-120"/>
+                        </a:rPr>
+                        <a:t>A letter representing an unknown (x, n, a).</a:t>
+                      </a:r>
+                      <a:endParaRPr lang="en-US" sz="1400" dirty="0">
+                        <a:latin typeface="Calibri" charset="0"/>
+                        <a:ea typeface="Calibri" charset="0"/>
+                        <a:cs typeface="Calibri" charset="0"/>
+                      </a:endParaRPr>
+                    </a:p>
+                  </a:txBody>
+                  <a:tcPr marL="91440" marR="91440" marT="45720" marB="45720">
+                    <a:lnL w="6350" cap="flat" cmpd="sng" algn="ctr">
+                      <a:solidFill>
+                        <a:srgbClr val="E5E2DC"/>
+                      </a:solidFill>
+                      <a:prstDash val="solid"/>
+                      <a:round/>
+                      <a:headEnd type="none" w="med" len="med"/>
+                      <a:tailEnd type="none" w="med" len="med"/>
+                    </a:lnL>
+                    <a:lnR w="6350" cap="flat" cmpd="sng" algn="ctr">
+                      <a:solidFill>
+                        <a:srgbClr val="E5E2DC"/>
+                      </a:solidFill>
+                      <a:prstDash val="solid"/>
+                      <a:round/>
+                      <a:headEnd type="none" w="med" len="med"/>
+                      <a:tailEnd type="none" w="med" len="med"/>
+                    </a:lnR>
+                    <a:lnT w="6350" cap="flat" cmpd="sng" algn="ctr">
+                      <a:solidFill>
+                        <a:srgbClr val="E5E2DC"/>
+                      </a:solidFill>
+                      <a:prstDash val="solid"/>
+                      <a:round/>
+                      <a:headEnd type="none" w="med" len="med"/>
+                      <a:tailEnd type="none" w="med" len="med"/>
+                    </a:lnT>
+                    <a:lnB w="6350" cap="flat" cmpd="sng" algn="ctr">
+                      <a:solidFill>
+                        <a:srgbClr val="E5E2DC"/>
+                      </a:solidFill>
+                      <a:prstDash val="solid"/>
+                      <a:round/>
+                      <a:headEnd type="none" w="med" len="med"/>
+                      <a:tailEnd type="none" w="med" len="med"/>
+                    </a:lnB>
+                  </a:tcPr>
+                </a:tc>
+              </a:tr>
+              <a:tr h="457200">
+                <a:tc>
+                  <a:txBody>
+                    <a:bodyPr/>
+                    <a:lstStyle/>
+                    <a:p>
+                      <a:pPr indent="0" marL="0">
+                        <a:buNone/>
+                      </a:pPr>
+                      <a:r>
+                        <a:rPr lang="en-US" sz="1400" b="1" dirty="0">
+                          <a:solidFill>
+                            <a:srgbClr val="1B2A4A"/>
+                          </a:solidFill>
+                          <a:latin typeface="Calibri" pitchFamily="34" charset="0"/>
+                          <a:ea typeface="Calibri" pitchFamily="34" charset="-122"/>
+                          <a:cs typeface="Calibri" pitchFamily="34" charset="-120"/>
+                        </a:rPr>
+                        <a:t>Coefficient</a:t>
+                      </a:r>
+                      <a:endParaRPr lang="en-US" sz="1400" dirty="0">
+                        <a:latin typeface="Calibri" charset="0"/>
+                        <a:ea typeface="Calibri" charset="0"/>
+                        <a:cs typeface="Calibri" charset="0"/>
+                      </a:endParaRPr>
+                    </a:p>
+                  </a:txBody>
+                  <a:tcPr marL="91440" marR="91440" marT="45720" marB="45720">
+                    <a:lnL w="6350" cap="flat" cmpd="sng" algn="ctr">
+                      <a:solidFill>
+                        <a:srgbClr val="E5E2DC"/>
+                      </a:solidFill>
+                      <a:prstDash val="solid"/>
+                      <a:round/>
+                      <a:headEnd type="none" w="med" len="med"/>
+                      <a:tailEnd type="none" w="med" len="med"/>
+                    </a:lnL>
+                    <a:lnR w="6350" cap="flat" cmpd="sng" algn="ctr">
+                      <a:solidFill>
+                        <a:srgbClr val="E5E2DC"/>
+                      </a:solidFill>
+                      <a:prstDash val="solid"/>
+                      <a:round/>
+                      <a:headEnd type="none" w="med" len="med"/>
+                      <a:tailEnd type="none" w="med" len="med"/>
+                    </a:lnR>
+                    <a:lnT w="6350" cap="flat" cmpd="sng" algn="ctr">
+                      <a:solidFill>
+                        <a:srgbClr val="E5E2DC"/>
+                      </a:solidFill>
+                      <a:prstDash val="solid"/>
+                      <a:round/>
+                      <a:headEnd type="none" w="med" len="med"/>
+                      <a:tailEnd type="none" w="med" len="med"/>
+                    </a:lnT>
+                    <a:lnB w="6350" cap="flat" cmpd="sng" algn="ctr">
+                      <a:solidFill>
+                        <a:srgbClr val="E5E2DC"/>
+                      </a:solidFill>
+                      <a:prstDash val="solid"/>
+                      <a:round/>
+                      <a:headEnd type="none" w="med" len="med"/>
+                      <a:tailEnd type="none" w="med" len="med"/>
+                    </a:lnB>
+                  </a:tcPr>
+                </a:tc>
+                <a:tc>
+                  <a:txBody>
+                    <a:bodyPr/>
+                    <a:lstStyle/>
+                    <a:p>
+                      <a:pPr indent="0" marL="0">
+                        <a:buNone/>
+                      </a:pPr>
+                      <a:r>
+                        <a:rPr lang="en-US" sz="1400" dirty="0">
+                          <a:solidFill>
+                            <a:srgbClr val="3D3A36"/>
+                          </a:solidFill>
+                          <a:latin typeface="Calibri" pitchFamily="34" charset="0"/>
+                          <a:ea typeface="Calibri" pitchFamily="34" charset="-122"/>
+                          <a:cs typeface="Calibri" pitchFamily="34" charset="-120"/>
+                        </a:rPr>
+                        <a:t>Number in front of a variable. In 3x, it's 3.</a:t>
+                      </a:r>
+                      <a:endParaRPr lang="en-US" sz="1400" dirty="0">
+                        <a:latin typeface="Calibri" charset="0"/>
+                        <a:ea typeface="Calibri" charset="0"/>
+                        <a:cs typeface="Calibri" charset="0"/>
+                      </a:endParaRPr>
+                    </a:p>
+                  </a:txBody>
+                  <a:tcPr marL="91440" marR="91440" marT="45720" marB="45720">
+                    <a:lnL w="6350" cap="flat" cmpd="sng" algn="ctr">
+                      <a:solidFill>
+                        <a:srgbClr val="E5E2DC"/>
+                      </a:solidFill>
+                      <a:prstDash val="solid"/>
+                      <a:round/>
+                      <a:headEnd type="none" w="med" len="med"/>
+                      <a:tailEnd type="none" w="med" len="med"/>
+                    </a:lnL>
+                    <a:lnR w="6350" cap="flat" cmpd="sng" algn="ctr">
+                      <a:solidFill>
+                        <a:srgbClr val="E5E2DC"/>
+                      </a:solidFill>
+                      <a:prstDash val="solid"/>
+                      <a:round/>
+                      <a:headEnd type="none" w="med" len="med"/>
+                      <a:tailEnd type="none" w="med" len="med"/>
+                    </a:lnR>
+                    <a:lnT w="6350" cap="flat" cmpd="sng" algn="ctr">
+                      <a:solidFill>
+                        <a:srgbClr val="E5E2DC"/>
+                      </a:solidFill>
+                      <a:prstDash val="solid"/>
+                      <a:round/>
+                      <a:headEnd type="none" w="med" len="med"/>
+                      <a:tailEnd type="none" w="med" len="med"/>
+                    </a:lnT>
+                    <a:lnB w="6350" cap="flat" cmpd="sng" algn="ctr">
+                      <a:solidFill>
+                        <a:srgbClr val="E5E2DC"/>
+                      </a:solidFill>
+                      <a:prstDash val="solid"/>
+                      <a:round/>
+                      <a:headEnd type="none" w="med" len="med"/>
+                      <a:tailEnd type="none" w="med" len="med"/>
+                    </a:lnB>
+                  </a:tcPr>
+                </a:tc>
+              </a:tr>
+              <a:tr h="457200">
+                <a:tc>
+                  <a:txBody>
+                    <a:bodyPr/>
+                    <a:lstStyle/>
+                    <a:p>
+                      <a:pPr indent="0" marL="0">
+                        <a:buNone/>
+                      </a:pPr>
+                      <a:r>
+                        <a:rPr lang="en-US" sz="1400" b="1" dirty="0">
+                          <a:solidFill>
+                            <a:srgbClr val="1B2A4A"/>
+                          </a:solidFill>
+                          <a:latin typeface="Calibri" pitchFamily="34" charset="0"/>
+                          <a:ea typeface="Calibri" pitchFamily="34" charset="-122"/>
+                          <a:cs typeface="Calibri" pitchFamily="34" charset="-120"/>
+                        </a:rPr>
+                        <a:t>Constant</a:t>
+                      </a:r>
+                      <a:endParaRPr lang="en-US" sz="1400" dirty="0">
+                        <a:latin typeface="Calibri" charset="0"/>
+                        <a:ea typeface="Calibri" charset="0"/>
+                        <a:cs typeface="Calibri" charset="0"/>
+                      </a:endParaRPr>
+                    </a:p>
+                  </a:txBody>
+                  <a:tcPr marL="91440" marR="91440" marT="45720" marB="45720">
+                    <a:lnL w="6350" cap="flat" cmpd="sng" algn="ctr">
+                      <a:solidFill>
+                        <a:srgbClr val="E5E2DC"/>
+                      </a:solidFill>
+                      <a:prstDash val="solid"/>
+                      <a:round/>
+                      <a:headEnd type="none" w="med" len="med"/>
+                      <a:tailEnd type="none" w="med" len="med"/>
+                    </a:lnL>
+                    <a:lnR w="6350" cap="flat" cmpd="sng" algn="ctr">
+                      <a:solidFill>
+                        <a:srgbClr val="E5E2DC"/>
+                      </a:solidFill>
+                      <a:prstDash val="solid"/>
+                      <a:round/>
+                      <a:headEnd type="none" w="med" len="med"/>
+                      <a:tailEnd type="none" w="med" len="med"/>
+                    </a:lnR>
+                    <a:lnT w="6350" cap="flat" cmpd="sng" algn="ctr">
+                      <a:solidFill>
+                        <a:srgbClr val="E5E2DC"/>
+                      </a:solidFill>
+                      <a:prstDash val="solid"/>
+                      <a:round/>
+                      <a:headEnd type="none" w="med" len="med"/>
+                      <a:tailEnd type="none" w="med" len="med"/>
+                    </a:lnT>
+                    <a:lnB w="6350" cap="flat" cmpd="sng" algn="ctr">
+                      <a:solidFill>
+                        <a:srgbClr val="E5E2DC"/>
+                      </a:solidFill>
+                      <a:prstDash val="solid"/>
+                      <a:round/>
+                      <a:headEnd type="none" w="med" len="med"/>
+                      <a:tailEnd type="none" w="med" len="med"/>
+                    </a:lnB>
+                  </a:tcPr>
+                </a:tc>
+                <a:tc>
+                  <a:txBody>
+                    <a:bodyPr/>
+                    <a:lstStyle/>
+                    <a:p>
+                      <a:pPr indent="0" marL="0">
+                        <a:buNone/>
+                      </a:pPr>
+                      <a:r>
+                        <a:rPr lang="en-US" sz="1400" dirty="0">
+                          <a:solidFill>
+                            <a:srgbClr val="3D3A36"/>
+                          </a:solidFill>
+                          <a:latin typeface="Calibri" pitchFamily="34" charset="0"/>
+                          <a:ea typeface="Calibri" pitchFamily="34" charset="-122"/>
+                          <a:cs typeface="Calibri" pitchFamily="34" charset="-120"/>
+                        </a:rPr>
+                        <a:t>Number on its own. In 3x + 5, it's 5.</a:t>
+                      </a:r>
+                      <a:endParaRPr lang="en-US" sz="1400" dirty="0">
+                        <a:latin typeface="Calibri" charset="0"/>
+                        <a:ea typeface="Calibri" charset="0"/>
+                        <a:cs typeface="Calibri" charset="0"/>
+                      </a:endParaRPr>
+                    </a:p>
+                  </a:txBody>
+                  <a:tcPr marL="91440" marR="91440" marT="45720" marB="45720">
+                    <a:lnL w="6350" cap="flat" cmpd="sng" algn="ctr">
+                      <a:solidFill>
+                        <a:srgbClr val="E5E2DC"/>
+                      </a:solidFill>
+                      <a:prstDash val="solid"/>
+                      <a:round/>
+                      <a:headEnd type="none" w="med" len="med"/>
+                      <a:tailEnd type="none" w="med" len="med"/>
+                    </a:lnL>
+                    <a:lnR w="6350" cap="flat" cmpd="sng" algn="ctr">
+                      <a:solidFill>
+                        <a:srgbClr val="E5E2DC"/>
+                      </a:solidFill>
+                      <a:prstDash val="solid"/>
+                      <a:round/>
+                      <a:headEnd type="none" w="med" len="med"/>
+                      <a:tailEnd type="none" w="med" len="med"/>
+                    </a:lnR>
+                    <a:lnT w="6350" cap="flat" cmpd="sng" algn="ctr">
+                      <a:solidFill>
+                        <a:srgbClr val="E5E2DC"/>
+                      </a:solidFill>
+                      <a:prstDash val="solid"/>
+                      <a:round/>
+                      <a:headEnd type="none" w="med" len="med"/>
+                      <a:tailEnd type="none" w="med" len="med"/>
+                    </a:lnT>
+                    <a:lnB w="6350" cap="flat" cmpd="sng" algn="ctr">
+                      <a:solidFill>
+                        <a:srgbClr val="E5E2DC"/>
+                      </a:solidFill>
+                      <a:prstDash val="solid"/>
+                      <a:round/>
+                      <a:headEnd type="none" w="med" len="med"/>
+                      <a:tailEnd type="none" w="med" len="med"/>
+                    </a:lnB>
+                  </a:tcPr>
+                </a:tc>
+              </a:tr>
+              <a:tr h="457200">
+                <a:tc>
+                  <a:txBody>
+                    <a:bodyPr/>
+                    <a:lstStyle/>
+                    <a:p>
+                      <a:pPr indent="0" marL="0">
+                        <a:buNone/>
+                      </a:pPr>
+                      <a:r>
+                        <a:rPr lang="en-US" sz="1400" b="1" dirty="0">
+                          <a:solidFill>
+                            <a:srgbClr val="1B2A4A"/>
+                          </a:solidFill>
+                          <a:latin typeface="Calibri" pitchFamily="34" charset="0"/>
+                          <a:ea typeface="Calibri" pitchFamily="34" charset="-122"/>
+                          <a:cs typeface="Calibri" pitchFamily="34" charset="-120"/>
+                        </a:rPr>
+                        <a:t>Term</a:t>
+                      </a:r>
+                      <a:endParaRPr lang="en-US" sz="1400" dirty="0">
+                        <a:latin typeface="Calibri" charset="0"/>
+                        <a:ea typeface="Calibri" charset="0"/>
+                        <a:cs typeface="Calibri" charset="0"/>
+                      </a:endParaRPr>
+                    </a:p>
+                  </a:txBody>
+                  <a:tcPr marL="91440" marR="91440" marT="45720" marB="45720">
+                    <a:lnL w="6350" cap="flat" cmpd="sng" algn="ctr">
+                      <a:solidFill>
+                        <a:srgbClr val="E5E2DC"/>
+                      </a:solidFill>
+                      <a:prstDash val="solid"/>
+                      <a:round/>
+                      <a:headEnd type="none" w="med" len="med"/>
+                      <a:tailEnd type="none" w="med" len="med"/>
+                    </a:lnL>
+                    <a:lnR w="6350" cap="flat" cmpd="sng" algn="ctr">
+                      <a:solidFill>
+                        <a:srgbClr val="E5E2DC"/>
+                      </a:solidFill>
+                      <a:prstDash val="solid"/>
+                      <a:round/>
+                      <a:headEnd type="none" w="med" len="med"/>
+                      <a:tailEnd type="none" w="med" len="med"/>
+                    </a:lnR>
+                    <a:lnT w="6350" cap="flat" cmpd="sng" algn="ctr">
+                      <a:solidFill>
+                        <a:srgbClr val="E5E2DC"/>
+                      </a:solidFill>
+                      <a:prstDash val="solid"/>
+                      <a:round/>
+                      <a:headEnd type="none" w="med" len="med"/>
+                      <a:tailEnd type="none" w="med" len="med"/>
+                    </a:lnT>
+                    <a:lnB w="6350" cap="flat" cmpd="sng" algn="ctr">
+                      <a:solidFill>
+                        <a:srgbClr val="E5E2DC"/>
+                      </a:solidFill>
+                      <a:prstDash val="solid"/>
+                      <a:round/>
+                      <a:headEnd type="none" w="med" len="med"/>
+                      <a:tailEnd type="none" w="med" len="med"/>
+                    </a:lnB>
+                  </a:tcPr>
+                </a:tc>
+                <a:tc>
+                  <a:txBody>
+                    <a:bodyPr/>
+                    <a:lstStyle/>
+                    <a:p>
+                      <a:pPr indent="0" marL="0">
+                        <a:buNone/>
+                      </a:pPr>
+                      <a:r>
+                        <a:rPr lang="en-US" sz="1400" dirty="0">
+                          <a:solidFill>
+                            <a:srgbClr val="3D3A36"/>
+                          </a:solidFill>
+                          <a:latin typeface="Calibri" pitchFamily="34" charset="0"/>
+                          <a:ea typeface="Calibri" pitchFamily="34" charset="-122"/>
+                          <a:cs typeface="Calibri" pitchFamily="34" charset="-120"/>
+                        </a:rPr>
+                        <a:t>Each part separated by + or −. In 3x + 5, there are 2 terms.</a:t>
+                      </a:r>
+                      <a:endParaRPr lang="en-US" sz="1400" dirty="0">
+                        <a:latin typeface="Calibri" charset="0"/>
+                        <a:ea typeface="Calibri" charset="0"/>
+                        <a:cs typeface="Calibri" charset="0"/>
+                      </a:endParaRPr>
+                    </a:p>
+                  </a:txBody>
+                  <a:tcPr marL="91440" marR="91440" marT="45720" marB="45720">
+                    <a:lnL w="6350" cap="flat" cmpd="sng" algn="ctr">
+                      <a:solidFill>
+                        <a:srgbClr val="E5E2DC"/>
+                      </a:solidFill>
+                      <a:prstDash val="solid"/>
+                      <a:round/>
+                      <a:headEnd type="none" w="med" len="med"/>
+                      <a:tailEnd type="none" w="med" len="med"/>
+                    </a:lnL>
+                    <a:lnR w="6350" cap="flat" cmpd="sng" algn="ctr">
+                      <a:solidFill>
+                        <a:srgbClr val="E5E2DC"/>
+                      </a:solidFill>
+                      <a:prstDash val="solid"/>
+                      <a:round/>
+                      <a:headEnd type="none" w="med" len="med"/>
+                      <a:tailEnd type="none" w="med" len="med"/>
+                    </a:lnR>
+                    <a:lnT w="6350" cap="flat" cmpd="sng" algn="ctr">
+                      <a:solidFill>
+                        <a:srgbClr val="E5E2DC"/>
+                      </a:solidFill>
+                      <a:prstDash val="solid"/>
+                      <a:round/>
+                      <a:headEnd type="none" w="med" len="med"/>
+                      <a:tailEnd type="none" w="med" len="med"/>
+                    </a:lnT>
+                    <a:lnB w="6350" cap="flat" cmpd="sng" algn="ctr">
+                      <a:solidFill>
+                        <a:srgbClr val="E5E2DC"/>
+                      </a:solidFill>
+                      <a:prstDash val="solid"/>
+                      <a:round/>
+                      <a:headEnd type="none" w="med" len="med"/>
+                      <a:tailEnd type="none" w="med" len="med"/>
+                    </a:lnB>
+                  </a:tcPr>
+                </a:tc>
+              </a:tr>
+            </a:tbl>
+          </a:graphicData>
+        </a:graphic>
+      </p:graphicFrame>
     </p:spTree>
   </p:cSld>
   <p:clrMapOvr>
@@ -2387,7 +3264,7 @@
     <p:bg>
       <p:bgPr>
         <a:solidFill>
-          <a:srgbClr val="1B2A4A"/>
+          <a:srgbClr val="FAF8F5"/>
         </a:solidFill>
       </p:bgPr>
     </p:bg>
@@ -2414,7 +3291,522 @@
         <p:spPr>
           <a:xfrm>
             <a:off x="0" y="0"/>
-            <a:ext cx="109728" cy="5143500"/>
+            <a:ext cx="9144000" cy="822960"/>
+          </a:xfrm>
+          <a:prstGeom prst="rect">
+            <a:avLst/>
+          </a:prstGeom>
+          <a:solidFill>
+            <a:srgbClr val="FFFFFF"/>
+          </a:solidFill>
+          <a:ln/>
+        </p:spPr>
+      </p:sp>
+      <p:sp>
+        <p:nvSpPr>
+          <p:cNvPr id="3" name="Shape 1"/>
+          <p:cNvSpPr/>
+          <p:nvPr/>
+        </p:nvSpPr>
+        <p:spPr>
+          <a:xfrm>
+            <a:off x="0" y="795528"/>
+            <a:ext cx="9144000" cy="27432"/>
+          </a:xfrm>
+          <a:prstGeom prst="rect">
+            <a:avLst/>
+          </a:prstGeom>
+          <a:solidFill>
+            <a:srgbClr val="2A9D8F"/>
+          </a:solidFill>
+          <a:ln/>
+        </p:spPr>
+      </p:sp>
+      <p:sp>
+        <p:nvSpPr>
+          <p:cNvPr id="4" name="Text 2"/>
+          <p:cNvSpPr/>
+          <p:nvPr/>
+        </p:nvSpPr>
+        <p:spPr>
+          <a:xfrm>
+            <a:off x="640080" y="91440"/>
+            <a:ext cx="7863840" cy="640080"/>
+          </a:xfrm>
+          <a:prstGeom prst="rect">
+            <a:avLst/>
+          </a:prstGeom>
+          <a:noFill/>
+          <a:ln/>
+        </p:spPr>
+        <p:txBody>
+          <a:bodyPr wrap="square" lIns="0" tIns="0" rIns="0" bIns="0" rtlCol="0" anchor="ctr"/>
+          <a:lstStyle/>
+          <a:p>
+            <a:pPr indent="0" marL="0">
+              <a:buNone/>
+            </a:pPr>
+            <a:r>
+              <a:rPr lang="en-US" sz="2200" b="1" dirty="0">
+                <a:solidFill>
+                  <a:srgbClr val="1B2A4A"/>
+                </a:solidFill>
+                <a:latin typeface="Georgia" pitchFamily="34" charset="0"/>
+                <a:ea typeface="Georgia" pitchFamily="34" charset="-122"/>
+                <a:cs typeface="Georgia" pitchFamily="34" charset="-120"/>
+              </a:rPr>
+              <a:t>Translating Words → Algebra</a:t>
+            </a:r>
+            <a:endParaRPr lang="en-US" sz="2200" dirty="0"/>
+          </a:p>
+        </p:txBody>
+      </p:sp>
+      <p:sp>
+        <p:nvSpPr>
+          <p:cNvPr id="5" name="Text 3"/>
+          <p:cNvSpPr/>
+          <p:nvPr/>
+        </p:nvSpPr>
+        <p:spPr>
+          <a:xfrm>
+            <a:off x="640080" y="1005840"/>
+            <a:ext cx="7863840" cy="2926080"/>
+          </a:xfrm>
+          <a:prstGeom prst="rect">
+            <a:avLst/>
+          </a:prstGeom>
+          <a:noFill/>
+          <a:ln/>
+        </p:spPr>
+        <p:txBody>
+          <a:bodyPr wrap="square" rtlCol="0" anchor="ctr"/>
+          <a:lstStyle/>
+          <a:p>
+            <a:pPr marL="342900" indent="-342900">
+              <a:spcAft>
+                <a:spcPts val="800"/>
+              </a:spcAft>
+              <a:buSzPct val="100000"/>
+              <a:buChar char="•"/>
+            </a:pPr>
+            <a:r>
+              <a:rPr lang="en-US" sz="1600" dirty="0">
+                <a:solidFill>
+                  <a:srgbClr val="3D3A36"/>
+                </a:solidFill>
+                <a:latin typeface="Calibri" pitchFamily="34" charset="0"/>
+                <a:ea typeface="Calibri" pitchFamily="34" charset="-122"/>
+                <a:cs typeface="Calibri" pitchFamily="34" charset="-120"/>
+              </a:rPr>
+              <a:t>'5 more than a number' → n + 5</a:t>
+            </a:r>
+            <a:endParaRPr lang="en-US" sz="1600" dirty="0"/>
+          </a:p>
+          <a:p>
+            <a:pPr marL="342900" indent="-342900">
+              <a:spcAft>
+                <a:spcPts val="800"/>
+              </a:spcAft>
+              <a:buSzPct val="100000"/>
+              <a:buChar char="•"/>
+            </a:pPr>
+            <a:r>
+              <a:rPr lang="en-US" sz="1600" dirty="0">
+                <a:solidFill>
+                  <a:srgbClr val="3D3A36"/>
+                </a:solidFill>
+                <a:latin typeface="Calibri" pitchFamily="34" charset="0"/>
+                <a:ea typeface="Calibri" pitchFamily="34" charset="-122"/>
+                <a:cs typeface="Calibri" pitchFamily="34" charset="-120"/>
+              </a:rPr>
+              <a:t>'3 times a number' → 3n</a:t>
+            </a:r>
+            <a:endParaRPr lang="en-US" sz="1600" dirty="0"/>
+          </a:p>
+          <a:p>
+            <a:pPr marL="342900" indent="-342900">
+              <a:spcAft>
+                <a:spcPts val="800"/>
+              </a:spcAft>
+              <a:buSzPct val="100000"/>
+              <a:buChar char="•"/>
+            </a:pPr>
+            <a:r>
+              <a:rPr lang="en-US" sz="1600" dirty="0">
+                <a:solidFill>
+                  <a:srgbClr val="3D3A36"/>
+                </a:solidFill>
+                <a:latin typeface="Calibri" pitchFamily="34" charset="0"/>
+                <a:ea typeface="Calibri" pitchFamily="34" charset="-122"/>
+                <a:cs typeface="Calibri" pitchFamily="34" charset="-120"/>
+              </a:rPr>
+              <a:t>'A number decreased by 7' → x − 7</a:t>
+            </a:r>
+            <a:endParaRPr lang="en-US" sz="1600" dirty="0"/>
+          </a:p>
+          <a:p>
+            <a:pPr marL="342900" indent="-342900">
+              <a:spcAft>
+                <a:spcPts val="800"/>
+              </a:spcAft>
+              <a:buSzPct val="100000"/>
+              <a:buChar char="•"/>
+            </a:pPr>
+            <a:r>
+              <a:rPr lang="en-US" sz="1600" dirty="0">
+                <a:solidFill>
+                  <a:srgbClr val="3D3A36"/>
+                </a:solidFill>
+                <a:latin typeface="Calibri" pitchFamily="34" charset="0"/>
+                <a:ea typeface="Calibri" pitchFamily="34" charset="-122"/>
+                <a:cs typeface="Calibri" pitchFamily="34" charset="-120"/>
+              </a:rPr>
+              <a:t>'Double a number then add 4' → 2n + 4</a:t>
+            </a:r>
+            <a:endParaRPr lang="en-US" sz="1600" dirty="0"/>
+          </a:p>
+          <a:p>
+            <a:pPr marL="342900" indent="-342900">
+              <a:spcAft>
+                <a:spcPts val="800"/>
+              </a:spcAft>
+              <a:buSzPct val="100000"/>
+              <a:buChar char="•"/>
+            </a:pPr>
+            <a:r>
+              <a:rPr lang="en-US" sz="1600" dirty="0">
+                <a:solidFill>
+                  <a:srgbClr val="3D3A36"/>
+                </a:solidFill>
+                <a:latin typeface="Calibri" pitchFamily="34" charset="0"/>
+                <a:ea typeface="Calibri" pitchFamily="34" charset="-122"/>
+                <a:cs typeface="Calibri" pitchFamily="34" charset="-120"/>
+              </a:rPr>
+              <a:t>Nanjing metro: cost = 2 + 1×n = n + 2</a:t>
+            </a:r>
+            <a:endParaRPr lang="en-US" sz="1600" dirty="0"/>
+          </a:p>
+        </p:txBody>
+      </p:sp>
+    </p:spTree>
+  </p:cSld>
+  <p:clrMapOvr>
+    <a:masterClrMapping/>
+  </p:clrMapOvr>
+</p:sld>
+</file>
+
+<file path=ppt/slides/slide6.xml><?xml version="1.0" encoding="utf-8"?>
+<p:sld xmlns:a="http://schemas.openxmlformats.org/drawingml/2006/main" xmlns:r="http://schemas.openxmlformats.org/officeDocument/2006/relationships" xmlns:p="http://schemas.openxmlformats.org/presentationml/2006/main">
+  <p:cSld name="Slide 6">
+    <p:bg>
+      <p:bgPr>
+        <a:solidFill>
+          <a:srgbClr val="FAF8F5"/>
+        </a:solidFill>
+      </p:bgPr>
+    </p:bg>
+    <p:spTree>
+      <p:nvGrpSpPr>
+        <p:cNvPr id="1" name=""/>
+        <p:cNvGrpSpPr/>
+        <p:nvPr/>
+      </p:nvGrpSpPr>
+      <p:grpSpPr>
+        <a:xfrm>
+          <a:off x="0" y="0"/>
+          <a:ext cx="0" cy="0"/>
+          <a:chOff x="0" y="0"/>
+          <a:chExt cx="0" cy="0"/>
+        </a:xfrm>
+      </p:grpSpPr>
+      <p:sp>
+        <p:nvSpPr>
+          <p:cNvPr id="2" name="Shape 0"/>
+          <p:cNvSpPr/>
+          <p:nvPr/>
+        </p:nvSpPr>
+        <p:spPr>
+          <a:xfrm>
+            <a:off x="0" y="0"/>
+            <a:ext cx="9144000" cy="822960"/>
+          </a:xfrm>
+          <a:prstGeom prst="rect">
+            <a:avLst/>
+          </a:prstGeom>
+          <a:solidFill>
+            <a:srgbClr val="FFFFFF"/>
+          </a:solidFill>
+          <a:ln/>
+        </p:spPr>
+      </p:sp>
+      <p:sp>
+        <p:nvSpPr>
+          <p:cNvPr id="3" name="Shape 1"/>
+          <p:cNvSpPr/>
+          <p:nvPr/>
+        </p:nvSpPr>
+        <p:spPr>
+          <a:xfrm>
+            <a:off x="0" y="795528"/>
+            <a:ext cx="9144000" cy="27432"/>
+          </a:xfrm>
+          <a:prstGeom prst="rect">
+            <a:avLst/>
+          </a:prstGeom>
+          <a:solidFill>
+            <a:srgbClr val="2A9D8F"/>
+          </a:solidFill>
+          <a:ln/>
+        </p:spPr>
+      </p:sp>
+      <p:sp>
+        <p:nvSpPr>
+          <p:cNvPr id="4" name="Text 2"/>
+          <p:cNvSpPr/>
+          <p:nvPr/>
+        </p:nvSpPr>
+        <p:spPr>
+          <a:xfrm>
+            <a:off x="640080" y="91440"/>
+            <a:ext cx="7863840" cy="640080"/>
+          </a:xfrm>
+          <a:prstGeom prst="rect">
+            <a:avLst/>
+          </a:prstGeom>
+          <a:noFill/>
+          <a:ln/>
+        </p:spPr>
+        <p:txBody>
+          <a:bodyPr wrap="square" lIns="0" tIns="0" rIns="0" bIns="0" rtlCol="0" anchor="ctr"/>
+          <a:lstStyle/>
+          <a:p>
+            <a:pPr indent="0" marL="0">
+              <a:buNone/>
+            </a:pPr>
+            <a:r>
+              <a:rPr lang="en-US" sz="2200" b="1" dirty="0">
+                <a:solidFill>
+                  <a:srgbClr val="1B2A4A"/>
+                </a:solidFill>
+                <a:latin typeface="Georgia" pitchFamily="34" charset="0"/>
+                <a:ea typeface="Georgia" pitchFamily="34" charset="-122"/>
+                <a:cs typeface="Georgia" pitchFamily="34" charset="-120"/>
+              </a:rPr>
+              <a:t>Real-World Expressions</a:t>
+            </a:r>
+            <a:endParaRPr lang="en-US" sz="2200" dirty="0"/>
+          </a:p>
+        </p:txBody>
+      </p:sp>
+      <p:sp>
+        <p:nvSpPr>
+          <p:cNvPr id="5" name="Shape 3"/>
+          <p:cNvSpPr/>
+          <p:nvPr/>
+        </p:nvSpPr>
+        <p:spPr>
+          <a:xfrm>
+            <a:off x="457200" y="1005840"/>
+            <a:ext cx="3931920" cy="3657600"/>
+          </a:xfrm>
+          <a:prstGeom prst="rect">
+            <a:avLst/>
+          </a:prstGeom>
+          <a:solidFill>
+            <a:srgbClr val="FFFFFF"/>
+          </a:solidFill>
+          <a:ln/>
+          <a:effectLst>
+            <a:outerShdw sx="100000" sy="100000" kx="0" ky="0" algn="bl" rotWithShape="0" blurRad="76200" dist="25400" dir="8100000">
+              <a:srgbClr val="000000">
+                <a:alpha val="12000"/>
+              </a:srgbClr>
+            </a:outerShdw>
+          </a:effectLst>
+        </p:spPr>
+      </p:sp>
+      <p:sp>
+        <p:nvSpPr>
+          <p:cNvPr id="6" name="Shape 4"/>
+          <p:cNvSpPr/>
+          <p:nvPr/>
+        </p:nvSpPr>
+        <p:spPr>
+          <a:xfrm>
+            <a:off x="457200" y="1005840"/>
+            <a:ext cx="3931920" cy="64008"/>
+          </a:xfrm>
+          <a:prstGeom prst="rect">
+            <a:avLst/>
+          </a:prstGeom>
+          <a:solidFill>
+            <a:srgbClr val="2A9D8F"/>
+          </a:solidFill>
+          <a:ln/>
+        </p:spPr>
+      </p:sp>
+      <p:sp>
+        <p:nvSpPr>
+          <p:cNvPr id="7" name="Text 5"/>
+          <p:cNvSpPr/>
+          <p:nvPr/>
+        </p:nvSpPr>
+        <p:spPr>
+          <a:xfrm>
+            <a:off x="640080" y="1188720"/>
+            <a:ext cx="3566160" cy="457200"/>
+          </a:xfrm>
+          <a:prstGeom prst="rect">
+            <a:avLst/>
+          </a:prstGeom>
+          <a:noFill/>
+          <a:ln/>
+        </p:spPr>
+        <p:txBody>
+          <a:bodyPr wrap="square" rtlCol="0" anchor="ctr"/>
+          <a:lstStyle/>
+          <a:p>
+            <a:pPr indent="0" marL="0">
+              <a:buNone/>
+            </a:pPr>
+            <a:r>
+              <a:rPr lang="en-US" sz="1600" b="1" dirty="0">
+                <a:solidFill>
+                  <a:srgbClr val="2A9D8F"/>
+                </a:solidFill>
+                <a:latin typeface="Calibri" pitchFamily="34" charset="0"/>
+                <a:ea typeface="Calibri" pitchFamily="34" charset="-122"/>
+                <a:cs typeface="Calibri" pitchFamily="34" charset="-120"/>
+              </a:rPr>
+              <a:t>Transport Costs</a:t>
+            </a:r>
+            <a:endParaRPr lang="en-US" sz="1600" dirty="0"/>
+          </a:p>
+        </p:txBody>
+      </p:sp>
+      <p:sp>
+        <p:nvSpPr>
+          <p:cNvPr id="8" name="Text 6"/>
+          <p:cNvSpPr/>
+          <p:nvPr/>
+        </p:nvSpPr>
+        <p:spPr>
+          <a:xfrm>
+            <a:off x="640080" y="1691640"/>
+            <a:ext cx="3566160" cy="2743200"/>
+          </a:xfrm>
+          <a:prstGeom prst="rect">
+            <a:avLst/>
+          </a:prstGeom>
+          <a:noFill/>
+          <a:ln/>
+        </p:spPr>
+        <p:txBody>
+          <a:bodyPr wrap="square" rtlCol="0" anchor="ctr"/>
+          <a:lstStyle/>
+          <a:p>
+            <a:pPr marL="342900" indent="-342900">
+              <a:spcAft>
+                <a:spcPts val="600"/>
+              </a:spcAft>
+              <a:buSzPct val="100000"/>
+              <a:buChar char="•"/>
+            </a:pPr>
+            <a:r>
+              <a:rPr lang="en-US" sz="1400" dirty="0">
+                <a:solidFill>
+                  <a:srgbClr val="3D3A36"/>
+                </a:solidFill>
+                <a:latin typeface="Calibri" pitchFamily="34" charset="0"/>
+                <a:ea typeface="Calibri" pitchFamily="34" charset="-122"/>
+                <a:cs typeface="Calibri" pitchFamily="34" charset="-120"/>
+              </a:rPr>
+              <a:t>Nanjing metro: 2 + n (¥ per station)</a:t>
+            </a:r>
+            <a:endParaRPr lang="en-US" sz="1400" dirty="0"/>
+          </a:p>
+          <a:p>
+            <a:pPr marL="342900" indent="-342900">
+              <a:spcAft>
+                <a:spcPts val="600"/>
+              </a:spcAft>
+              <a:buSzPct val="100000"/>
+              <a:buChar char="•"/>
+            </a:pPr>
+            <a:r>
+              <a:rPr lang="en-US" sz="1400" dirty="0">
+                <a:solidFill>
+                  <a:srgbClr val="3D3A36"/>
+                </a:solidFill>
+                <a:latin typeface="Calibri" pitchFamily="34" charset="0"/>
+                <a:ea typeface="Calibri" pitchFamily="34" charset="-122"/>
+                <a:cs typeface="Calibri" pitchFamily="34" charset="-120"/>
+              </a:rPr>
+              <a:t>Seoul subway: 1250 + 100d (₩ per km)</a:t>
+            </a:r>
+            <a:endParaRPr lang="en-US" sz="1400" dirty="0"/>
+          </a:p>
+          <a:p>
+            <a:pPr marL="342900" indent="-342900">
+              <a:spcAft>
+                <a:spcPts val="600"/>
+              </a:spcAft>
+              <a:buSzPct val="100000"/>
+              <a:buChar char="•"/>
+            </a:pPr>
+            <a:r>
+              <a:rPr lang="en-US" sz="1400" dirty="0">
+                <a:solidFill>
+                  <a:srgbClr val="3D3A36"/>
+                </a:solidFill>
+                <a:latin typeface="Calibri" pitchFamily="34" charset="0"/>
+                <a:ea typeface="Calibri" pitchFamily="34" charset="-122"/>
+                <a:cs typeface="Calibri" pitchFamily="34" charset="-120"/>
+              </a:rPr>
+              <a:t>Berlin bus: 3.20 (flat fare — a constant!)</a:t>
+            </a:r>
+            <a:endParaRPr lang="en-US" sz="1400" dirty="0"/>
+          </a:p>
+        </p:txBody>
+      </p:sp>
+      <p:sp>
+        <p:nvSpPr>
+          <p:cNvPr id="9" name="Shape 7"/>
+          <p:cNvSpPr/>
+          <p:nvPr/>
+        </p:nvSpPr>
+        <p:spPr>
+          <a:xfrm>
+            <a:off x="4754880" y="1005840"/>
+            <a:ext cx="3931920" cy="3657600"/>
+          </a:xfrm>
+          <a:prstGeom prst="rect">
+            <a:avLst/>
+          </a:prstGeom>
+          <a:solidFill>
+            <a:srgbClr val="FFFFFF"/>
+          </a:solidFill>
+          <a:ln/>
+          <a:effectLst>
+            <a:outerShdw sx="100000" sy="100000" kx="0" ky="0" algn="bl" rotWithShape="0" blurRad="76200" dist="25400" dir="8100000">
+              <a:srgbClr val="000000">
+                <a:alpha val="12000"/>
+              </a:srgbClr>
+            </a:outerShdw>
+          </a:effectLst>
+        </p:spPr>
+      </p:sp>
+      <p:sp>
+        <p:nvSpPr>
+          <p:cNvPr id="10" name="Shape 8"/>
+          <p:cNvSpPr/>
+          <p:nvPr/>
+        </p:nvSpPr>
+        <p:spPr>
+          <a:xfrm>
+            <a:off x="4754880" y="1005840"/>
+            <a:ext cx="3931920" cy="64008"/>
           </a:xfrm>
           <a:prstGeom prst="rect">
             <a:avLst/>
@@ -2427,14 +3819,14 @@
       </p:sp>
       <p:sp>
         <p:nvSpPr>
-          <p:cNvPr id="3" name="Text 1"/>
-          <p:cNvSpPr/>
-          <p:nvPr/>
-        </p:nvSpPr>
-        <p:spPr>
-          <a:xfrm>
-            <a:off x="731520" y="457200"/>
-            <a:ext cx="7772400" cy="731520"/>
+          <p:cNvPr id="11" name="Text 9"/>
+          <p:cNvSpPr/>
+          <p:nvPr/>
+        </p:nvSpPr>
+        <p:spPr>
+          <a:xfrm>
+            <a:off x="4937760" y="1188720"/>
+            <a:ext cx="3566160" cy="457200"/>
           </a:xfrm>
           <a:prstGeom prst="rect">
             <a:avLst/>
@@ -2450,7 +3842,1141 @@
               <a:buNone/>
             </a:pPr>
             <a:r>
-              <a:rPr lang="en-US" sz="3200" b="1" dirty="0">
+              <a:rPr lang="en-US" sz="1600" b="1" dirty="0">
+                <a:solidFill>
+                  <a:srgbClr val="E9C46A"/>
+                </a:solidFill>
+                <a:latin typeface="Calibri" pitchFamily="34" charset="0"/>
+                <a:ea typeface="Calibri" pitchFamily="34" charset="-122"/>
+                <a:cs typeface="Calibri" pitchFamily="34" charset="-120"/>
+              </a:rPr>
+              <a:t>Shopping</a:t>
+            </a:r>
+            <a:endParaRPr lang="en-US" sz="1600" dirty="0"/>
+          </a:p>
+        </p:txBody>
+      </p:sp>
+      <p:sp>
+        <p:nvSpPr>
+          <p:cNvPr id="12" name="Text 10"/>
+          <p:cNvSpPr/>
+          <p:nvPr/>
+        </p:nvSpPr>
+        <p:spPr>
+          <a:xfrm>
+            <a:off x="4937760" y="1691640"/>
+            <a:ext cx="3566160" cy="2743200"/>
+          </a:xfrm>
+          <a:prstGeom prst="rect">
+            <a:avLst/>
+          </a:prstGeom>
+          <a:noFill/>
+          <a:ln/>
+        </p:spPr>
+        <p:txBody>
+          <a:bodyPr wrap="square" rtlCol="0" anchor="ctr"/>
+          <a:lstStyle/>
+          <a:p>
+            <a:pPr marL="342900" indent="-342900">
+              <a:spcAft>
+                <a:spcPts val="600"/>
+              </a:spcAft>
+              <a:buSzPct val="100000"/>
+              <a:buChar char="•"/>
+            </a:pPr>
+            <a:r>
+              <a:rPr lang="en-US" sz="1400" dirty="0">
+                <a:solidFill>
+                  <a:srgbClr val="3D3A36"/>
+                </a:solidFill>
+                <a:latin typeface="Calibri" pitchFamily="34" charset="0"/>
+                <a:ea typeface="Calibri" pitchFamily="34" charset="-122"/>
+                <a:cs typeface="Calibri" pitchFamily="34" charset="-120"/>
+              </a:rPr>
+              <a:t>German bakery: 3b + 0.5r (bread + rolls)</a:t>
+            </a:r>
+            <a:endParaRPr lang="en-US" sz="1400" dirty="0"/>
+          </a:p>
+          <a:p>
+            <a:pPr marL="342900" indent="-342900">
+              <a:spcAft>
+                <a:spcPts val="600"/>
+              </a:spcAft>
+              <a:buSzPct val="100000"/>
+              <a:buChar char="•"/>
+            </a:pPr>
+            <a:r>
+              <a:rPr lang="en-US" sz="1400" dirty="0">
+                <a:solidFill>
+                  <a:srgbClr val="3D3A36"/>
+                </a:solidFill>
+                <a:latin typeface="Calibri" pitchFamily="34" charset="0"/>
+                <a:ea typeface="Calibri" pitchFamily="34" charset="-122"/>
+                <a:cs typeface="Calibri" pitchFamily="34" charset="-120"/>
+              </a:rPr>
+              <a:t>Korean BBQ: 15000p + 5000 (per person + table)</a:t>
+            </a:r>
+            <a:endParaRPr lang="en-US" sz="1400" dirty="0"/>
+          </a:p>
+          <a:p>
+            <a:pPr marL="342900" indent="-342900">
+              <a:spcAft>
+                <a:spcPts val="600"/>
+              </a:spcAft>
+              <a:buSzPct val="100000"/>
+              <a:buChar char="•"/>
+            </a:pPr>
+            <a:r>
+              <a:rPr lang="en-US" sz="1400" dirty="0">
+                <a:solidFill>
+                  <a:srgbClr val="3D3A36"/>
+                </a:solidFill>
+                <a:latin typeface="Calibri" pitchFamily="34" charset="0"/>
+                <a:ea typeface="Calibri" pitchFamily="34" charset="-122"/>
+                <a:cs typeface="Calibri" pitchFamily="34" charset="-120"/>
+              </a:rPr>
+              <a:t>Bubble tea: 18 + 3t (base + toppings)</a:t>
+            </a:r>
+            <a:endParaRPr lang="en-US" sz="1400" dirty="0"/>
+          </a:p>
+        </p:txBody>
+      </p:sp>
+    </p:spTree>
+  </p:cSld>
+  <p:clrMapOvr>
+    <a:masterClrMapping/>
+  </p:clrMapOvr>
+</p:sld>
+</file>
+
+<file path=ppt/slides/slide7.xml><?xml version="1.0" encoding="utf-8"?>
+<p:sld xmlns:a="http://schemas.openxmlformats.org/drawingml/2006/main" xmlns:r="http://schemas.openxmlformats.org/officeDocument/2006/relationships" xmlns:p="http://schemas.openxmlformats.org/presentationml/2006/main">
+  <p:cSld name="Slide 7">
+    <p:bg>
+      <p:bgPr>
+        <a:solidFill>
+          <a:srgbClr val="FAF8F5"/>
+        </a:solidFill>
+      </p:bgPr>
+    </p:bg>
+    <p:spTree>
+      <p:nvGrpSpPr>
+        <p:cNvPr id="1" name=""/>
+        <p:cNvGrpSpPr/>
+        <p:nvPr/>
+      </p:nvGrpSpPr>
+      <p:grpSpPr>
+        <a:xfrm>
+          <a:off x="0" y="0"/>
+          <a:ext cx="0" cy="0"/>
+          <a:chOff x="0" y="0"/>
+          <a:chExt cx="0" cy="0"/>
+        </a:xfrm>
+      </p:grpSpPr>
+      <p:sp>
+        <p:nvSpPr>
+          <p:cNvPr id="2" name="Shape 0"/>
+          <p:cNvSpPr/>
+          <p:nvPr/>
+        </p:nvSpPr>
+        <p:spPr>
+          <a:xfrm>
+            <a:off x="0" y="0"/>
+            <a:ext cx="9144000" cy="822960"/>
+          </a:xfrm>
+          <a:prstGeom prst="rect">
+            <a:avLst/>
+          </a:prstGeom>
+          <a:solidFill>
+            <a:srgbClr val="FFFFFF"/>
+          </a:solidFill>
+          <a:ln/>
+        </p:spPr>
+      </p:sp>
+      <p:sp>
+        <p:nvSpPr>
+          <p:cNvPr id="3" name="Shape 1"/>
+          <p:cNvSpPr/>
+          <p:nvPr/>
+        </p:nvSpPr>
+        <p:spPr>
+          <a:xfrm>
+            <a:off x="0" y="795528"/>
+            <a:ext cx="9144000" cy="27432"/>
+          </a:xfrm>
+          <a:prstGeom prst="rect">
+            <a:avLst/>
+          </a:prstGeom>
+          <a:solidFill>
+            <a:srgbClr val="2A9D8F"/>
+          </a:solidFill>
+          <a:ln/>
+        </p:spPr>
+      </p:sp>
+      <p:sp>
+        <p:nvSpPr>
+          <p:cNvPr id="4" name="Text 2"/>
+          <p:cNvSpPr/>
+          <p:nvPr/>
+        </p:nvSpPr>
+        <p:spPr>
+          <a:xfrm>
+            <a:off x="640080" y="91440"/>
+            <a:ext cx="7863840" cy="640080"/>
+          </a:xfrm>
+          <a:prstGeom prst="rect">
+            <a:avLst/>
+          </a:prstGeom>
+          <a:noFill/>
+          <a:ln/>
+        </p:spPr>
+        <p:txBody>
+          <a:bodyPr wrap="square" lIns="0" tIns="0" rIns="0" bIns="0" rtlCol="0" anchor="ctr"/>
+          <a:lstStyle/>
+          <a:p>
+            <a:pPr indent="0" marL="0">
+              <a:buNone/>
+            </a:pPr>
+            <a:r>
+              <a:rPr lang="en-US" sz="2200" b="1" dirty="0">
+                <a:solidFill>
+                  <a:srgbClr val="1B2A4A"/>
+                </a:solidFill>
+                <a:latin typeface="Georgia" pitchFamily="34" charset="0"/>
+                <a:ea typeface="Georgia" pitchFamily="34" charset="-122"/>
+                <a:cs typeface="Georgia" pitchFamily="34" charset="-120"/>
+              </a:rPr>
+              <a:t>Simplifying: Combining Like Terms</a:t>
+            </a:r>
+            <a:endParaRPr lang="en-US" sz="2200" dirty="0"/>
+          </a:p>
+        </p:txBody>
+      </p:sp>
+      <p:sp>
+        <p:nvSpPr>
+          <p:cNvPr id="5" name="Text 3"/>
+          <p:cNvSpPr/>
+          <p:nvPr/>
+        </p:nvSpPr>
+        <p:spPr>
+          <a:xfrm>
+            <a:off x="640080" y="1005840"/>
+            <a:ext cx="7863840" cy="2926080"/>
+          </a:xfrm>
+          <a:prstGeom prst="rect">
+            <a:avLst/>
+          </a:prstGeom>
+          <a:noFill/>
+          <a:ln/>
+        </p:spPr>
+        <p:txBody>
+          <a:bodyPr wrap="square" rtlCol="0" anchor="ctr"/>
+          <a:lstStyle/>
+          <a:p>
+            <a:pPr marL="342900" indent="-342900">
+              <a:spcAft>
+                <a:spcPts val="800"/>
+              </a:spcAft>
+              <a:buSzPct val="100000"/>
+              <a:buChar char="•"/>
+            </a:pPr>
+            <a:r>
+              <a:rPr lang="en-US" sz="1600" dirty="0">
+                <a:solidFill>
+                  <a:srgbClr val="3D3A36"/>
+                </a:solidFill>
+                <a:latin typeface="Calibri" pitchFamily="34" charset="0"/>
+                <a:ea typeface="Calibri" pitchFamily="34" charset="-122"/>
+                <a:cs typeface="Calibri" pitchFamily="34" charset="-120"/>
+              </a:rPr>
+              <a:t>Like terms = same variable, same power.</a:t>
+            </a:r>
+            <a:endParaRPr lang="en-US" sz="1600" dirty="0"/>
+          </a:p>
+          <a:p>
+            <a:pPr marL="342900" indent="-342900">
+              <a:spcAft>
+                <a:spcPts val="800"/>
+              </a:spcAft>
+              <a:buSzPct val="100000"/>
+              <a:buChar char="•"/>
+            </a:pPr>
+            <a:r>
+              <a:rPr lang="en-US" sz="1600" dirty="0">
+                <a:solidFill>
+                  <a:srgbClr val="3D3A36"/>
+                </a:solidFill>
+                <a:latin typeface="Calibri" pitchFamily="34" charset="0"/>
+                <a:ea typeface="Calibri" pitchFamily="34" charset="-122"/>
+                <a:cs typeface="Calibri" pitchFamily="34" charset="-120"/>
+              </a:rPr>
+              <a:t>3x + 5x = 8x (both are 'x' terms).</a:t>
+            </a:r>
+            <a:endParaRPr lang="en-US" sz="1600" dirty="0"/>
+          </a:p>
+          <a:p>
+            <a:pPr marL="342900" indent="-342900">
+              <a:spcAft>
+                <a:spcPts val="800"/>
+              </a:spcAft>
+              <a:buSzPct val="100000"/>
+              <a:buChar char="•"/>
+            </a:pPr>
+            <a:r>
+              <a:rPr lang="en-US" sz="1600" dirty="0">
+                <a:solidFill>
+                  <a:srgbClr val="3D3A36"/>
+                </a:solidFill>
+                <a:latin typeface="Calibri" pitchFamily="34" charset="0"/>
+                <a:ea typeface="Calibri" pitchFamily="34" charset="-122"/>
+                <a:cs typeface="Calibri" pitchFamily="34" charset="-120"/>
+              </a:rPr>
+              <a:t>3x + 2y — cannot simplify (different variables).</a:t>
+            </a:r>
+            <a:endParaRPr lang="en-US" sz="1600" dirty="0"/>
+          </a:p>
+          <a:p>
+            <a:pPr marL="342900" indent="-342900">
+              <a:spcAft>
+                <a:spcPts val="800"/>
+              </a:spcAft>
+              <a:buSzPct val="100000"/>
+              <a:buChar char="•"/>
+            </a:pPr>
+            <a:r>
+              <a:rPr lang="en-US" sz="1600" dirty="0">
+                <a:solidFill>
+                  <a:srgbClr val="3D3A36"/>
+                </a:solidFill>
+                <a:latin typeface="Calibri" pitchFamily="34" charset="0"/>
+                <a:ea typeface="Calibri" pitchFamily="34" charset="-122"/>
+                <a:cs typeface="Calibri" pitchFamily="34" charset="-120"/>
+              </a:rPr>
+              <a:t>4a + 3 + 2a − 1 = 6a + 2.</a:t>
+            </a:r>
+            <a:endParaRPr lang="en-US" sz="1600" dirty="0"/>
+          </a:p>
+        </p:txBody>
+      </p:sp>
+      <p:sp>
+        <p:nvSpPr>
+          <p:cNvPr id="6" name="Shape 4"/>
+          <p:cNvSpPr/>
+          <p:nvPr/>
+        </p:nvSpPr>
+        <p:spPr>
+          <a:xfrm>
+            <a:off x="640080" y="4114800"/>
+            <a:ext cx="7863840" cy="731520"/>
+          </a:xfrm>
+          <a:prstGeom prst="rect">
+            <a:avLst/>
+          </a:prstGeom>
+          <a:solidFill>
+            <a:srgbClr val="E8F5F3"/>
+          </a:solidFill>
+          <a:ln/>
+          <a:effectLst>
+            <a:outerShdw sx="100000" sy="100000" kx="0" ky="0" algn="bl" rotWithShape="0" blurRad="76200" dist="25400" dir="8100000">
+              <a:srgbClr val="000000">
+                <a:alpha val="12000"/>
+              </a:srgbClr>
+            </a:outerShdw>
+          </a:effectLst>
+        </p:spPr>
+      </p:sp>
+      <p:sp>
+        <p:nvSpPr>
+          <p:cNvPr id="7" name="Shape 5"/>
+          <p:cNvSpPr/>
+          <p:nvPr/>
+        </p:nvSpPr>
+        <p:spPr>
+          <a:xfrm>
+            <a:off x="640080" y="4114800"/>
+            <a:ext cx="64008" cy="731520"/>
+          </a:xfrm>
+          <a:prstGeom prst="rect">
+            <a:avLst/>
+          </a:prstGeom>
+          <a:solidFill>
+            <a:srgbClr val="2A9D8F"/>
+          </a:solidFill>
+          <a:ln/>
+        </p:spPr>
+      </p:sp>
+      <p:sp>
+        <p:nvSpPr>
+          <p:cNvPr id="8" name="Text 6"/>
+          <p:cNvSpPr/>
+          <p:nvPr/>
+        </p:nvSpPr>
+        <p:spPr>
+          <a:xfrm>
+            <a:off x="914400" y="4160520"/>
+            <a:ext cx="7406640" cy="640080"/>
+          </a:xfrm>
+          <a:prstGeom prst="rect">
+            <a:avLst/>
+          </a:prstGeom>
+          <a:noFill/>
+          <a:ln/>
+        </p:spPr>
+        <p:txBody>
+          <a:bodyPr wrap="square" rtlCol="0" anchor="ctr"/>
+          <a:lstStyle/>
+          <a:p>
+            <a:pPr indent="0" marL="0">
+              <a:buNone/>
+            </a:pPr>
+            <a:r>
+              <a:rPr lang="en-US" sz="1300" i="1" dirty="0">
+                <a:solidFill>
+                  <a:srgbClr val="3D3A36"/>
+                </a:solidFill>
+                <a:latin typeface="Calibri" pitchFamily="34" charset="0"/>
+                <a:ea typeface="Calibri" pitchFamily="34" charset="-122"/>
+                <a:cs typeface="Calibri" pitchFamily="34" charset="-120"/>
+              </a:rPr>
+              <a:t>Think: 3 apples + 5 apples = 8 apples. Can't add apples and bananas.</a:t>
+            </a:r>
+            <a:endParaRPr lang="en-US" sz="1300" dirty="0"/>
+          </a:p>
+        </p:txBody>
+      </p:sp>
+    </p:spTree>
+  </p:cSld>
+  <p:clrMapOvr>
+    <a:masterClrMapping/>
+  </p:clrMapOvr>
+</p:sld>
+</file>
+
+<file path=ppt/slides/slide8.xml><?xml version="1.0" encoding="utf-8"?>
+<p:sld xmlns:a="http://schemas.openxmlformats.org/drawingml/2006/main" xmlns:r="http://schemas.openxmlformats.org/officeDocument/2006/relationships" xmlns:p="http://schemas.openxmlformats.org/presentationml/2006/main">
+  <p:cSld name="Slide 8">
+    <p:bg>
+      <p:bgPr>
+        <a:solidFill>
+          <a:srgbClr val="FAF8F5"/>
+        </a:solidFill>
+      </p:bgPr>
+    </p:bg>
+    <p:spTree>
+      <p:nvGrpSpPr>
+        <p:cNvPr id="1" name=""/>
+        <p:cNvGrpSpPr/>
+        <p:nvPr/>
+      </p:nvGrpSpPr>
+      <p:grpSpPr>
+        <a:xfrm>
+          <a:off x="0" y="0"/>
+          <a:ext cx="0" cy="0"/>
+          <a:chOff x="0" y="0"/>
+          <a:chExt cx="0" cy="0"/>
+        </a:xfrm>
+      </p:grpSpPr>
+      <p:sp>
+        <p:nvSpPr>
+          <p:cNvPr id="2" name="Shape 0"/>
+          <p:cNvSpPr/>
+          <p:nvPr/>
+        </p:nvSpPr>
+        <p:spPr>
+          <a:xfrm>
+            <a:off x="0" y="0"/>
+            <a:ext cx="9144000" cy="822960"/>
+          </a:xfrm>
+          <a:prstGeom prst="rect">
+            <a:avLst/>
+          </a:prstGeom>
+          <a:solidFill>
+            <a:srgbClr val="FFFFFF"/>
+          </a:solidFill>
+          <a:ln/>
+        </p:spPr>
+      </p:sp>
+      <p:sp>
+        <p:nvSpPr>
+          <p:cNvPr id="3" name="Shape 1"/>
+          <p:cNvSpPr/>
+          <p:nvPr/>
+        </p:nvSpPr>
+        <p:spPr>
+          <a:xfrm>
+            <a:off x="0" y="795528"/>
+            <a:ext cx="9144000" cy="27432"/>
+          </a:xfrm>
+          <a:prstGeom prst="rect">
+            <a:avLst/>
+          </a:prstGeom>
+          <a:solidFill>
+            <a:srgbClr val="2A9D8F"/>
+          </a:solidFill>
+          <a:ln/>
+        </p:spPr>
+      </p:sp>
+      <p:sp>
+        <p:nvSpPr>
+          <p:cNvPr id="4" name="Text 2"/>
+          <p:cNvSpPr/>
+          <p:nvPr/>
+        </p:nvSpPr>
+        <p:spPr>
+          <a:xfrm>
+            <a:off x="640080" y="91440"/>
+            <a:ext cx="7863840" cy="640080"/>
+          </a:xfrm>
+          <a:prstGeom prst="rect">
+            <a:avLst/>
+          </a:prstGeom>
+          <a:noFill/>
+          <a:ln/>
+        </p:spPr>
+        <p:txBody>
+          <a:bodyPr wrap="square" lIns="0" tIns="0" rIns="0" bIns="0" rtlCol="0" anchor="ctr"/>
+          <a:lstStyle/>
+          <a:p>
+            <a:pPr indent="0" marL="0">
+              <a:buNone/>
+            </a:pPr>
+            <a:r>
+              <a:rPr lang="en-US" sz="2200" b="1" dirty="0">
+                <a:solidFill>
+                  <a:srgbClr val="1B2A4A"/>
+                </a:solidFill>
+                <a:latin typeface="Georgia" pitchFamily="34" charset="0"/>
+                <a:ea typeface="Georgia" pitchFamily="34" charset="-122"/>
+                <a:cs typeface="Georgia" pitchFamily="34" charset="-120"/>
+              </a:rPr>
+              <a:t>Recommended Videos</a:t>
+            </a:r>
+            <a:endParaRPr lang="en-US" sz="2200" dirty="0"/>
+          </a:p>
+        </p:txBody>
+      </p:sp>
+      <p:sp>
+        <p:nvSpPr>
+          <p:cNvPr id="5" name="Text 3"/>
+          <p:cNvSpPr/>
+          <p:nvPr/>
+        </p:nvSpPr>
+        <p:spPr>
+          <a:xfrm>
+            <a:off x="640080" y="868680"/>
+            <a:ext cx="7863840" cy="274320"/>
+          </a:xfrm>
+          <a:prstGeom prst="rect">
+            <a:avLst/>
+          </a:prstGeom>
+          <a:noFill/>
+          <a:ln/>
+        </p:spPr>
+        <p:txBody>
+          <a:bodyPr wrap="square" rtlCol="0" anchor="ctr"/>
+          <a:lstStyle/>
+          <a:p>
+            <a:pPr indent="0" marL="0">
+              <a:buNone/>
+            </a:pPr>
+            <a:r>
+              <a:rPr lang="en-US" sz="1200" i="1" dirty="0">
+                <a:solidFill>
+                  <a:srgbClr val="6B6660"/>
+                </a:solidFill>
+                <a:latin typeface="Calibri" pitchFamily="34" charset="0"/>
+                <a:ea typeface="Calibri" pitchFamily="34" charset="-122"/>
+                <a:cs typeface="Calibri" pitchFamily="34" charset="-120"/>
+              </a:rPr>
+              <a:t>Search these on YouTube to learn more.</a:t>
+            </a:r>
+            <a:endParaRPr lang="en-US" sz="1200" dirty="0"/>
+          </a:p>
+        </p:txBody>
+      </p:sp>
+      <p:sp>
+        <p:nvSpPr>
+          <p:cNvPr id="6" name="Shape 4"/>
+          <p:cNvSpPr/>
+          <p:nvPr/>
+        </p:nvSpPr>
+        <p:spPr>
+          <a:xfrm>
+            <a:off x="457200" y="1234440"/>
+            <a:ext cx="8229600" cy="1051560"/>
+          </a:xfrm>
+          <a:prstGeom prst="rect">
+            <a:avLst/>
+          </a:prstGeom>
+          <a:solidFill>
+            <a:srgbClr val="FFFFFF"/>
+          </a:solidFill>
+          <a:ln/>
+          <a:effectLst>
+            <a:outerShdw sx="100000" sy="100000" kx="0" ky="0" algn="bl" rotWithShape="0" blurRad="76200" dist="25400" dir="8100000">
+              <a:srgbClr val="000000">
+                <a:alpha val="12000"/>
+              </a:srgbClr>
+            </a:outerShdw>
+          </a:effectLst>
+        </p:spPr>
+      </p:sp>
+      <p:sp>
+        <p:nvSpPr>
+          <p:cNvPr id="7" name="Shape 5"/>
+          <p:cNvSpPr/>
+          <p:nvPr/>
+        </p:nvSpPr>
+        <p:spPr>
+          <a:xfrm>
+            <a:off x="457200" y="1234440"/>
+            <a:ext cx="64008" cy="1051560"/>
+          </a:xfrm>
+          <a:prstGeom prst="rect">
+            <a:avLst/>
+          </a:prstGeom>
+          <a:solidFill>
+            <a:srgbClr val="2A9D8F"/>
+          </a:solidFill>
+          <a:ln/>
+        </p:spPr>
+      </p:sp>
+      <p:sp>
+        <p:nvSpPr>
+          <p:cNvPr id="8" name="Text 6"/>
+          <p:cNvSpPr/>
+          <p:nvPr/>
+        </p:nvSpPr>
+        <p:spPr>
+          <a:xfrm>
+            <a:off x="640080" y="1325880"/>
+            <a:ext cx="457200" cy="457200"/>
+          </a:xfrm>
+          <a:prstGeom prst="rect">
+            <a:avLst/>
+          </a:prstGeom>
+          <a:noFill/>
+          <a:ln/>
+        </p:spPr>
+        <p:txBody>
+          <a:bodyPr wrap="square" rtlCol="0" anchor="ctr"/>
+          <a:lstStyle/>
+          <a:p>
+            <a:pPr algn="ctr" indent="0" marL="0">
+              <a:buNone/>
+            </a:pPr>
+            <a:r>
+              <a:rPr lang="en-US" sz="2000" dirty="0">
+                <a:solidFill>
+                  <a:srgbClr val="2A9D8F"/>
+                </a:solidFill>
+                <a:latin typeface="Calibri" pitchFamily="34" charset="0"/>
+                <a:ea typeface="Calibri" pitchFamily="34" charset="-122"/>
+                <a:cs typeface="Calibri" pitchFamily="34" charset="-120"/>
+              </a:rPr>
+              <a:t>▶</a:t>
+            </a:r>
+            <a:endParaRPr lang="en-US" sz="2000" dirty="0"/>
+          </a:p>
+        </p:txBody>
+      </p:sp>
+      <p:sp>
+        <p:nvSpPr>
+          <p:cNvPr id="9" name="Text 7"/>
+          <p:cNvSpPr/>
+          <p:nvPr/>
+        </p:nvSpPr>
+        <p:spPr>
+          <a:xfrm>
+            <a:off x="1188720" y="1307592"/>
+            <a:ext cx="7132320" cy="411480"/>
+          </a:xfrm>
+          <a:prstGeom prst="rect">
+            <a:avLst/>
+          </a:prstGeom>
+          <a:noFill/>
+          <a:ln/>
+        </p:spPr>
+        <p:txBody>
+          <a:bodyPr wrap="square" rtlCol="0" anchor="ctr"/>
+          <a:lstStyle/>
+          <a:p>
+            <a:pPr indent="0" marL="0">
+              <a:buNone/>
+            </a:pPr>
+            <a:r>
+              <a:rPr lang="en-US" sz="1400" b="1" dirty="0">
+                <a:solidFill>
+                  <a:srgbClr val="1B2A4A"/>
+                </a:solidFill>
+                <a:latin typeface="Calibri" pitchFamily="34" charset="0"/>
+                <a:ea typeface="Calibri" pitchFamily="34" charset="-122"/>
+                <a:cs typeface="Calibri" pitchFamily="34" charset="-120"/>
+              </a:rPr>
+              <a:t>What Are Algebraic Expressions?</a:t>
+            </a:r>
+            <a:endParaRPr lang="en-US" sz="1400" dirty="0"/>
+          </a:p>
+        </p:txBody>
+      </p:sp>
+      <p:sp>
+        <p:nvSpPr>
+          <p:cNvPr id="10" name="Text 8"/>
+          <p:cNvSpPr/>
+          <p:nvPr/>
+        </p:nvSpPr>
+        <p:spPr>
+          <a:xfrm>
+            <a:off x="1188720" y="1691640"/>
+            <a:ext cx="7132320" cy="320040"/>
+          </a:xfrm>
+          <a:prstGeom prst="rect">
+            <a:avLst/>
+          </a:prstGeom>
+          <a:noFill/>
+          <a:ln/>
+        </p:spPr>
+        <p:txBody>
+          <a:bodyPr wrap="square" rtlCol="0" anchor="ctr"/>
+          <a:lstStyle/>
+          <a:p>
+            <a:pPr indent="0" marL="0">
+              <a:buNone/>
+            </a:pPr>
+            <a:r>
+              <a:rPr lang="en-US" sz="1100" dirty="0">
+                <a:solidFill>
+                  <a:srgbClr val="6B6660"/>
+                </a:solidFill>
+                <a:latin typeface="Calibri" pitchFamily="34" charset="0"/>
+                <a:ea typeface="Calibri" pitchFamily="34" charset="-122"/>
+                <a:cs typeface="Calibri" pitchFamily="34" charset="-120"/>
+              </a:rPr>
+              <a:t>Math Antics  •  9 min</a:t>
+            </a:r>
+            <a:endParaRPr lang="en-US" sz="1100" dirty="0"/>
+          </a:p>
+        </p:txBody>
+      </p:sp>
+      <p:sp>
+        <p:nvSpPr>
+          <p:cNvPr id="11" name="Shape 9"/>
+          <p:cNvSpPr/>
+          <p:nvPr/>
+        </p:nvSpPr>
+        <p:spPr>
+          <a:xfrm>
+            <a:off x="457200" y="2423160"/>
+            <a:ext cx="8229600" cy="1051560"/>
+          </a:xfrm>
+          <a:prstGeom prst="rect">
+            <a:avLst/>
+          </a:prstGeom>
+          <a:solidFill>
+            <a:srgbClr val="FFFFFF"/>
+          </a:solidFill>
+          <a:ln/>
+          <a:effectLst>
+            <a:outerShdw sx="100000" sy="100000" kx="0" ky="0" algn="bl" rotWithShape="0" blurRad="76200" dist="25400" dir="8100000">
+              <a:srgbClr val="000000">
+                <a:alpha val="12000"/>
+              </a:srgbClr>
+            </a:outerShdw>
+          </a:effectLst>
+        </p:spPr>
+      </p:sp>
+      <p:sp>
+        <p:nvSpPr>
+          <p:cNvPr id="12" name="Shape 10"/>
+          <p:cNvSpPr/>
+          <p:nvPr/>
+        </p:nvSpPr>
+        <p:spPr>
+          <a:xfrm>
+            <a:off x="457200" y="2423160"/>
+            <a:ext cx="64008" cy="1051560"/>
+          </a:xfrm>
+          <a:prstGeom prst="rect">
+            <a:avLst/>
+          </a:prstGeom>
+          <a:solidFill>
+            <a:srgbClr val="2A9D8F"/>
+          </a:solidFill>
+          <a:ln/>
+        </p:spPr>
+      </p:sp>
+      <p:sp>
+        <p:nvSpPr>
+          <p:cNvPr id="13" name="Text 11"/>
+          <p:cNvSpPr/>
+          <p:nvPr/>
+        </p:nvSpPr>
+        <p:spPr>
+          <a:xfrm>
+            <a:off x="640080" y="2514600"/>
+            <a:ext cx="457200" cy="457200"/>
+          </a:xfrm>
+          <a:prstGeom prst="rect">
+            <a:avLst/>
+          </a:prstGeom>
+          <a:noFill/>
+          <a:ln/>
+        </p:spPr>
+        <p:txBody>
+          <a:bodyPr wrap="square" rtlCol="0" anchor="ctr"/>
+          <a:lstStyle/>
+          <a:p>
+            <a:pPr algn="ctr" indent="0" marL="0">
+              <a:buNone/>
+            </a:pPr>
+            <a:r>
+              <a:rPr lang="en-US" sz="2000" dirty="0">
+                <a:solidFill>
+                  <a:srgbClr val="2A9D8F"/>
+                </a:solidFill>
+                <a:latin typeface="Calibri" pitchFamily="34" charset="0"/>
+                <a:ea typeface="Calibri" pitchFamily="34" charset="-122"/>
+                <a:cs typeface="Calibri" pitchFamily="34" charset="-120"/>
+              </a:rPr>
+              <a:t>▶</a:t>
+            </a:r>
+            <a:endParaRPr lang="en-US" sz="2000" dirty="0"/>
+          </a:p>
+        </p:txBody>
+      </p:sp>
+      <p:sp>
+        <p:nvSpPr>
+          <p:cNvPr id="14" name="Text 12"/>
+          <p:cNvSpPr/>
+          <p:nvPr/>
+        </p:nvSpPr>
+        <p:spPr>
+          <a:xfrm>
+            <a:off x="1188720" y="2496312"/>
+            <a:ext cx="7132320" cy="411480"/>
+          </a:xfrm>
+          <a:prstGeom prst="rect">
+            <a:avLst/>
+          </a:prstGeom>
+          <a:noFill/>
+          <a:ln/>
+        </p:spPr>
+        <p:txBody>
+          <a:bodyPr wrap="square" rtlCol="0" anchor="ctr"/>
+          <a:lstStyle/>
+          <a:p>
+            <a:pPr indent="0" marL="0">
+              <a:buNone/>
+            </a:pPr>
+            <a:r>
+              <a:rPr lang="en-US" sz="1400" b="1" dirty="0">
+                <a:solidFill>
+                  <a:srgbClr val="1B2A4A"/>
+                </a:solidFill>
+                <a:latin typeface="Calibri" pitchFamily="34" charset="0"/>
+                <a:ea typeface="Calibri" pitchFamily="34" charset="-122"/>
+                <a:cs typeface="Calibri" pitchFamily="34" charset="-120"/>
+              </a:rPr>
+              <a:t>Algebraic Expressions — Simplifying</a:t>
+            </a:r>
+            <a:endParaRPr lang="en-US" sz="1400" dirty="0"/>
+          </a:p>
+        </p:txBody>
+      </p:sp>
+      <p:sp>
+        <p:nvSpPr>
+          <p:cNvPr id="15" name="Text 13"/>
+          <p:cNvSpPr/>
+          <p:nvPr/>
+        </p:nvSpPr>
+        <p:spPr>
+          <a:xfrm>
+            <a:off x="1188720" y="2880360"/>
+            <a:ext cx="7132320" cy="320040"/>
+          </a:xfrm>
+          <a:prstGeom prst="rect">
+            <a:avLst/>
+          </a:prstGeom>
+          <a:noFill/>
+          <a:ln/>
+        </p:spPr>
+        <p:txBody>
+          <a:bodyPr wrap="square" rtlCol="0" anchor="ctr"/>
+          <a:lstStyle/>
+          <a:p>
+            <a:pPr indent="0" marL="0">
+              <a:buNone/>
+            </a:pPr>
+            <a:r>
+              <a:rPr lang="en-US" sz="1100" dirty="0">
+                <a:solidFill>
+                  <a:srgbClr val="6B6660"/>
+                </a:solidFill>
+                <a:latin typeface="Calibri" pitchFamily="34" charset="0"/>
+                <a:ea typeface="Calibri" pitchFamily="34" charset="-122"/>
+                <a:cs typeface="Calibri" pitchFamily="34" charset="-120"/>
+              </a:rPr>
+              <a:t>Corbettmaths  •  5 min</a:t>
+            </a:r>
+            <a:endParaRPr lang="en-US" sz="1100" dirty="0"/>
+          </a:p>
+        </p:txBody>
+      </p:sp>
+      <p:sp>
+        <p:nvSpPr>
+          <p:cNvPr id="16" name="Shape 14"/>
+          <p:cNvSpPr/>
+          <p:nvPr/>
+        </p:nvSpPr>
+        <p:spPr>
+          <a:xfrm>
+            <a:off x="457200" y="3611880"/>
+            <a:ext cx="8229600" cy="1051560"/>
+          </a:xfrm>
+          <a:prstGeom prst="rect">
+            <a:avLst/>
+          </a:prstGeom>
+          <a:solidFill>
+            <a:srgbClr val="FFFFFF"/>
+          </a:solidFill>
+          <a:ln/>
+          <a:effectLst>
+            <a:outerShdw sx="100000" sy="100000" kx="0" ky="0" algn="bl" rotWithShape="0" blurRad="76200" dist="25400" dir="8100000">
+              <a:srgbClr val="000000">
+                <a:alpha val="12000"/>
+              </a:srgbClr>
+            </a:outerShdw>
+          </a:effectLst>
+        </p:spPr>
+      </p:sp>
+      <p:sp>
+        <p:nvSpPr>
+          <p:cNvPr id="17" name="Shape 15"/>
+          <p:cNvSpPr/>
+          <p:nvPr/>
+        </p:nvSpPr>
+        <p:spPr>
+          <a:xfrm>
+            <a:off x="457200" y="3611880"/>
+            <a:ext cx="64008" cy="1051560"/>
+          </a:xfrm>
+          <a:prstGeom prst="rect">
+            <a:avLst/>
+          </a:prstGeom>
+          <a:solidFill>
+            <a:srgbClr val="2A9D8F"/>
+          </a:solidFill>
+          <a:ln/>
+        </p:spPr>
+      </p:sp>
+      <p:sp>
+        <p:nvSpPr>
+          <p:cNvPr id="18" name="Text 16"/>
+          <p:cNvSpPr/>
+          <p:nvPr/>
+        </p:nvSpPr>
+        <p:spPr>
+          <a:xfrm>
+            <a:off x="640080" y="3703320"/>
+            <a:ext cx="457200" cy="457200"/>
+          </a:xfrm>
+          <a:prstGeom prst="rect">
+            <a:avLst/>
+          </a:prstGeom>
+          <a:noFill/>
+          <a:ln/>
+        </p:spPr>
+        <p:txBody>
+          <a:bodyPr wrap="square" rtlCol="0" anchor="ctr"/>
+          <a:lstStyle/>
+          <a:p>
+            <a:pPr algn="ctr" indent="0" marL="0">
+              <a:buNone/>
+            </a:pPr>
+            <a:r>
+              <a:rPr lang="en-US" sz="2000" dirty="0">
+                <a:solidFill>
+                  <a:srgbClr val="2A9D8F"/>
+                </a:solidFill>
+                <a:latin typeface="Calibri" pitchFamily="34" charset="0"/>
+                <a:ea typeface="Calibri" pitchFamily="34" charset="-122"/>
+                <a:cs typeface="Calibri" pitchFamily="34" charset="-120"/>
+              </a:rPr>
+              <a:t>▶</a:t>
+            </a:r>
+            <a:endParaRPr lang="en-US" sz="2000" dirty="0"/>
+          </a:p>
+        </p:txBody>
+      </p:sp>
+      <p:sp>
+        <p:nvSpPr>
+          <p:cNvPr id="19" name="Text 17"/>
+          <p:cNvSpPr/>
+          <p:nvPr/>
+        </p:nvSpPr>
+        <p:spPr>
+          <a:xfrm>
+            <a:off x="1188720" y="3685032"/>
+            <a:ext cx="7132320" cy="411480"/>
+          </a:xfrm>
+          <a:prstGeom prst="rect">
+            <a:avLst/>
+          </a:prstGeom>
+          <a:noFill/>
+          <a:ln/>
+        </p:spPr>
+        <p:txBody>
+          <a:bodyPr wrap="square" rtlCol="0" anchor="ctr"/>
+          <a:lstStyle/>
+          <a:p>
+            <a:pPr indent="0" marL="0">
+              <a:buNone/>
+            </a:pPr>
+            <a:r>
+              <a:rPr lang="en-US" sz="1400" b="1" dirty="0">
+                <a:solidFill>
+                  <a:srgbClr val="1B2A4A"/>
+                </a:solidFill>
+                <a:latin typeface="Calibri" pitchFamily="34" charset="0"/>
+                <a:ea typeface="Calibri" pitchFamily="34" charset="-122"/>
+                <a:cs typeface="Calibri" pitchFamily="34" charset="-120"/>
+              </a:rPr>
+              <a:t>Like Terms and Simplifying</a:t>
+            </a:r>
+            <a:endParaRPr lang="en-US" sz="1400" dirty="0"/>
+          </a:p>
+        </p:txBody>
+      </p:sp>
+      <p:sp>
+        <p:nvSpPr>
+          <p:cNvPr id="20" name="Text 18"/>
+          <p:cNvSpPr/>
+          <p:nvPr/>
+        </p:nvSpPr>
+        <p:spPr>
+          <a:xfrm>
+            <a:off x="1188720" y="4069080"/>
+            <a:ext cx="7132320" cy="320040"/>
+          </a:xfrm>
+          <a:prstGeom prst="rect">
+            <a:avLst/>
+          </a:prstGeom>
+          <a:noFill/>
+          <a:ln/>
+        </p:spPr>
+        <p:txBody>
+          <a:bodyPr wrap="square" rtlCol="0" anchor="ctr"/>
+          <a:lstStyle/>
+          <a:p>
+            <a:pPr indent="0" marL="0">
+              <a:buNone/>
+            </a:pPr>
+            <a:r>
+              <a:rPr lang="en-US" sz="1100" dirty="0">
+                <a:solidFill>
+                  <a:srgbClr val="6B6660"/>
+                </a:solidFill>
+                <a:latin typeface="Calibri" pitchFamily="34" charset="0"/>
+                <a:ea typeface="Calibri" pitchFamily="34" charset="-122"/>
+                <a:cs typeface="Calibri" pitchFamily="34" charset="-120"/>
+              </a:rPr>
+              <a:t>Cognito  •  4 min</a:t>
+            </a:r>
+            <a:endParaRPr lang="en-US" sz="1100" dirty="0"/>
+          </a:p>
+        </p:txBody>
+      </p:sp>
+    </p:spTree>
+  </p:cSld>
+  <p:clrMapOvr>
+    <a:masterClrMapping/>
+  </p:clrMapOvr>
+</p:sld>
+</file>
+
+<file path=ppt/slides/slide9.xml><?xml version="1.0" encoding="utf-8"?>
+<p:sld xmlns:a="http://schemas.openxmlformats.org/drawingml/2006/main" xmlns:r="http://schemas.openxmlformats.org/officeDocument/2006/relationships" xmlns:p="http://schemas.openxmlformats.org/presentationml/2006/main">
+  <p:cSld name="Slide 9">
+    <p:spTree>
+      <p:nvGrpSpPr>
+        <p:cNvPr id="1" name=""/>
+        <p:cNvGrpSpPr/>
+        <p:nvPr/>
+      </p:nvGrpSpPr>
+      <p:grpSpPr>
+        <a:xfrm>
+          <a:off x="0" y="0"/>
+          <a:ext cx="0" cy="0"/>
+          <a:chOff x="0" y="0"/>
+          <a:chExt cx="0" cy="0"/>
+        </a:xfrm>
+      </p:grpSpPr>
+      <p:sp>
+        <p:nvSpPr>
+          <p:cNvPr id="2" name="Shape 0"/>
+          <p:cNvSpPr/>
+          <p:nvPr/>
+        </p:nvSpPr>
+        <p:spPr>
+          <a:xfrm>
+            <a:off x="0" y="0"/>
+            <a:ext cx="9144000" cy="5143500"/>
+          </a:xfrm>
+          <a:prstGeom prst="rect">
+            <a:avLst/>
+          </a:prstGeom>
+          <a:solidFill>
+            <a:srgbClr val="1B2A4A"/>
+          </a:solidFill>
+          <a:ln/>
+        </p:spPr>
+      </p:sp>
+      <p:sp>
+        <p:nvSpPr>
+          <p:cNvPr id="3" name="Shape 1"/>
+          <p:cNvSpPr/>
+          <p:nvPr/>
+        </p:nvSpPr>
+        <p:spPr>
+          <a:xfrm>
+            <a:off x="0" y="4777740"/>
+            <a:ext cx="9144000" cy="365760"/>
+          </a:xfrm>
+          <a:prstGeom prst="rect">
+            <a:avLst/>
+          </a:prstGeom>
+          <a:solidFill>
+            <a:srgbClr val="2A9D8F"/>
+          </a:solidFill>
+          <a:ln/>
+        </p:spPr>
+      </p:sp>
+      <p:sp>
+        <p:nvSpPr>
+          <p:cNvPr id="4" name="Text 2"/>
+          <p:cNvSpPr/>
+          <p:nvPr/>
+        </p:nvSpPr>
+        <p:spPr>
+          <a:xfrm>
+            <a:off x="731520" y="1371600"/>
+            <a:ext cx="7680960" cy="914400"/>
+          </a:xfrm>
+          <a:prstGeom prst="rect">
+            <a:avLst/>
+          </a:prstGeom>
+          <a:noFill/>
+          <a:ln/>
+        </p:spPr>
+        <p:txBody>
+          <a:bodyPr wrap="square" rtlCol="0" anchor="ctr"/>
+          <a:lstStyle/>
+          <a:p>
+            <a:pPr algn="ctr" indent="0" marL="0">
+              <a:buNone/>
+            </a:pPr>
+            <a:r>
+              <a:rPr lang="en-US" sz="3600" b="1" dirty="0">
                 <a:solidFill>
                   <a:srgbClr val="FFFFFF"/>
                 </a:solidFill>
@@ -2458,22 +4984,22 @@
                 <a:ea typeface="Georgia" pitchFamily="34" charset="-122"/>
                 <a:cs typeface="Georgia" pitchFamily="34" charset="-120"/>
               </a:rPr>
-              <a:t>Key Takeaways</a:t>
-            </a:r>
-            <a:endParaRPr lang="en-US" sz="3200" dirty="0"/>
-          </a:p>
-        </p:txBody>
-      </p:sp>
-      <p:sp>
-        <p:nvSpPr>
-          <p:cNvPr id="4" name="Text 2"/>
-          <p:cNvSpPr/>
-          <p:nvPr/>
-        </p:nvSpPr>
-        <p:spPr>
-          <a:xfrm>
-            <a:off x="731520" y="1463040"/>
-            <a:ext cx="7772400" cy="3200400"/>
+              <a:t>Review &amp; Practise</a:t>
+            </a:r>
+            <a:endParaRPr lang="en-US" sz="3600" dirty="0"/>
+          </a:p>
+        </p:txBody>
+      </p:sp>
+      <p:sp>
+        <p:nvSpPr>
+          <p:cNvPr id="5" name="Text 3"/>
+          <p:cNvSpPr/>
+          <p:nvPr/>
+        </p:nvSpPr>
+        <p:spPr>
+          <a:xfrm>
+            <a:off x="731520" y="2560320"/>
+            <a:ext cx="7680960" cy="548640"/>
           </a:xfrm>
           <a:prstGeom prst="rect">
             <a:avLst/>
@@ -2482,143 +5008,16 @@
           <a:ln/>
         </p:spPr>
         <p:txBody>
-          <a:bodyPr wrap="square" rtlCol="0" anchor="t"/>
-          <a:lstStyle/>
-          <a:p>
-            <a:pPr marL="342900" indent="-342900">
-              <a:spcAft>
-                <a:spcPts val="1000"/>
-              </a:spcAft>
-              <a:buSzPct val="100000"/>
-              <a:buChar char="•"/>
-            </a:pPr>
-            <a:r>
-              <a:rPr lang="en-US" sz="1500" dirty="0">
-                <a:solidFill>
-                  <a:srgbClr val="CADCFC"/>
-                </a:solidFill>
-                <a:latin typeface="Calibri" pitchFamily="34" charset="0"/>
-                <a:ea typeface="Calibri" pitchFamily="34" charset="-122"/>
-                <a:cs typeface="Calibri" pitchFamily="34" charset="-120"/>
-              </a:rPr>
-              <a:t>Algebra uses letters for unknown numbers</a:t>
-            </a:r>
-            <a:endParaRPr lang="en-US" sz="1500" dirty="0"/>
-          </a:p>
-          <a:p>
-            <a:pPr marL="342900" indent="-342900">
-              <a:spcAft>
-                <a:spcPts val="1000"/>
-              </a:spcAft>
-              <a:buSzPct val="100000"/>
-              <a:buChar char="•"/>
-            </a:pPr>
-            <a:r>
-              <a:rPr lang="en-US" sz="1500" dirty="0">
-                <a:solidFill>
-                  <a:srgbClr val="CADCFC"/>
-                </a:solidFill>
-                <a:latin typeface="Calibri" pitchFamily="34" charset="0"/>
-                <a:ea typeface="Calibri" pitchFamily="34" charset="-122"/>
-                <a:cs typeface="Calibri" pitchFamily="34" charset="-120"/>
-              </a:rPr>
-              <a:t>Translate words: 'double n plus 3' → 2n + 3</a:t>
-            </a:r>
-            <a:endParaRPr lang="en-US" sz="1500" dirty="0"/>
-          </a:p>
-          <a:p>
-            <a:pPr marL="342900" indent="-342900">
-              <a:spcAft>
-                <a:spcPts val="1000"/>
-              </a:spcAft>
-              <a:buSzPct val="100000"/>
-              <a:buChar char="•"/>
-            </a:pPr>
-            <a:r>
-              <a:rPr lang="en-US" sz="1500" dirty="0">
-                <a:solidFill>
-                  <a:srgbClr val="CADCFC"/>
-                </a:solidFill>
-                <a:latin typeface="Calibri" pitchFamily="34" charset="0"/>
-                <a:ea typeface="Calibri" pitchFamily="34" charset="-122"/>
-                <a:cs typeface="Calibri" pitchFamily="34" charset="-120"/>
-              </a:rPr>
-              <a:t>No × sign: write 3x not 3 × x. Number before letter.</a:t>
-            </a:r>
-            <a:endParaRPr lang="en-US" sz="1500" dirty="0"/>
-          </a:p>
-          <a:p>
-            <a:pPr marL="342900" indent="-342900">
-              <a:spcAft>
-                <a:spcPts val="1000"/>
-              </a:spcAft>
-              <a:buSzPct val="100000"/>
-              <a:buChar char="•"/>
-            </a:pPr>
-            <a:r>
-              <a:rPr lang="en-US" sz="1500" dirty="0">
-                <a:solidFill>
-                  <a:srgbClr val="CADCFC"/>
-                </a:solidFill>
-                <a:latin typeface="Calibri" pitchFamily="34" charset="0"/>
-                <a:ea typeface="Calibri" pitchFamily="34" charset="-122"/>
-                <a:cs typeface="Calibri" pitchFamily="34" charset="-120"/>
-              </a:rPr>
-              <a:t>Like terms: same letter. Combine by adding/subtracting coefficients</a:t>
-            </a:r>
-            <a:endParaRPr lang="en-US" sz="1500" dirty="0"/>
-          </a:p>
-          <a:p>
-            <a:pPr marL="342900" indent="-342900">
-              <a:spcAft>
-                <a:spcPts val="1000"/>
-              </a:spcAft>
-              <a:buSzPct val="100000"/>
-              <a:buChar char="•"/>
-            </a:pPr>
-            <a:r>
-              <a:rPr lang="en-US" sz="1500" dirty="0">
-                <a:solidFill>
-                  <a:srgbClr val="CADCFC"/>
-                </a:solidFill>
-                <a:latin typeface="Calibri" pitchFamily="34" charset="0"/>
-                <a:ea typeface="Calibri" pitchFamily="34" charset="-122"/>
-                <a:cs typeface="Calibri" pitchFamily="34" charset="-120"/>
-              </a:rPr>
-              <a:t>Cannot combine different letters: 3x + 2y stays as is</a:t>
-            </a:r>
-            <a:endParaRPr lang="en-US" sz="1500" dirty="0"/>
-          </a:p>
-        </p:txBody>
-      </p:sp>
-      <p:sp>
-        <p:nvSpPr>
-          <p:cNvPr id="5" name="Text 3"/>
-          <p:cNvSpPr/>
-          <p:nvPr/>
-        </p:nvSpPr>
-        <p:spPr>
-          <a:xfrm>
-            <a:off x="731520" y="4572000"/>
-            <a:ext cx="7772400" cy="365760"/>
-          </a:xfrm>
-          <a:prstGeom prst="rect">
-            <a:avLst/>
-          </a:prstGeom>
-          <a:noFill/>
-          <a:ln/>
-        </p:spPr>
-        <p:txBody>
           <a:bodyPr wrap="square" rtlCol="0" anchor="ctr"/>
           <a:lstStyle/>
           <a:p>
-            <a:pPr indent="0" marL="0">
+            <a:pPr algn="ctr" indent="0" marL="0">
               <a:buNone/>
             </a:pPr>
             <a:r>
-              <a:rPr lang="en-US" sz="1100" dirty="0">
+              <a:rPr lang="en-US" sz="2000" dirty="0">
                 <a:solidFill>
-                  <a:srgbClr val="E9C46A"/>
+                  <a:srgbClr val="2A9D8F"/>
                 </a:solidFill>
                 <a:latin typeface="Calibri" pitchFamily="34" charset="0"/>
                 <a:ea typeface="Calibri" pitchFamily="34" charset="-122"/>
@@ -2626,7 +5025,7 @@
               </a:rPr>
               <a:t>mrzocchi.com</a:t>
             </a:r>
-            <a:endParaRPr lang="en-US" sz="1100" dirty="0"/>
+            <a:endParaRPr lang="en-US" sz="2000" dirty="0"/>
           </a:p>
         </p:txBody>
       </p:sp>

</xml_diff>